<commit_message>
docs: resolve July 30 presentation redlines
</commit_message>
<xml_diff>
--- a/CARE2.0_transfer_update_2026-07-30.pptx
+++ b/CARE2.0_transfer_update_2026-07-30.pptx
@@ -2,27 +2,27 @@
 <file path=ppt/presentation.xml><?xml version="1.0" encoding="utf-8"?>
 <p:presentation xmlns:p="http://schemas.openxmlformats.org/presentationml/2006/main">
   <p:sldMasterIdLst>
-    <p:sldMasterId xmlns:r="http://schemas.openxmlformats.org/officeDocument/2006/relationships" id="2147483648" r:id="R10ee8480960a4317"/>
+    <p:sldMasterId xmlns:r="http://schemas.openxmlformats.org/officeDocument/2006/relationships" id="2147483648" r:id="R43fd7fa95a934351"/>
   </p:sldMasterIdLst>
   <p:notesMasterIdLst>
-    <p:notesMasterId xmlns:r="http://schemas.openxmlformats.org/officeDocument/2006/relationships" r:id="R53027db1053c4206"/>
+    <p:notesMasterId xmlns:r="http://schemas.openxmlformats.org/officeDocument/2006/relationships" r:id="Rc1000d08207e41ae"/>
   </p:notesMasterIdLst>
   <p:sldIdLst>
-    <p:sldId xmlns:r="http://schemas.openxmlformats.org/officeDocument/2006/relationships" id="256" r:id="R998cf80714c54f7c"/>
-    <p:sldId xmlns:r="http://schemas.openxmlformats.org/officeDocument/2006/relationships" id="257" r:id="R59f7e1e9b7da4757"/>
-    <p:sldId xmlns:r="http://schemas.openxmlformats.org/officeDocument/2006/relationships" id="258" r:id="R306f88ef19b84ae4"/>
-    <p:sldId xmlns:r="http://schemas.openxmlformats.org/officeDocument/2006/relationships" id="259" r:id="Rde72f4e272c740b7"/>
-    <p:sldId xmlns:r="http://schemas.openxmlformats.org/officeDocument/2006/relationships" id="260" r:id="R4b38685ef3a9446c"/>
-    <p:sldId xmlns:r="http://schemas.openxmlformats.org/officeDocument/2006/relationships" id="261" r:id="Rc1443cedc8fb4d45"/>
-    <p:sldId xmlns:r="http://schemas.openxmlformats.org/officeDocument/2006/relationships" id="262" r:id="R8fd797f55cd045fb"/>
-    <p:sldId xmlns:r="http://schemas.openxmlformats.org/officeDocument/2006/relationships" id="263" r:id="R292000bd8fd442b9"/>
-    <p:sldId xmlns:r="http://schemas.openxmlformats.org/officeDocument/2006/relationships" id="264" r:id="R053e5c36ebb343a6"/>
-    <p:sldId xmlns:r="http://schemas.openxmlformats.org/officeDocument/2006/relationships" id="265" r:id="R4c83b0f6fd6a4103"/>
-    <p:sldId xmlns:r="http://schemas.openxmlformats.org/officeDocument/2006/relationships" id="266" r:id="Re0d28684f26d4c80"/>
-    <p:sldId xmlns:r="http://schemas.openxmlformats.org/officeDocument/2006/relationships" id="267" r:id="Rfa1659862aa44d55"/>
-    <p:sldId xmlns:r="http://schemas.openxmlformats.org/officeDocument/2006/relationships" id="268" r:id="R65cf955b491e4e3e"/>
-    <p:sldId xmlns:r="http://schemas.openxmlformats.org/officeDocument/2006/relationships" id="269" r:id="R75e1f8234b454132"/>
-    <p:sldId xmlns:r="http://schemas.openxmlformats.org/officeDocument/2006/relationships" id="270" r:id="R037470c1f41f4d79"/>
+    <p:sldId xmlns:r="http://schemas.openxmlformats.org/officeDocument/2006/relationships" id="256" r:id="Rd2999a3da9e84c4b"/>
+    <p:sldId xmlns:r="http://schemas.openxmlformats.org/officeDocument/2006/relationships" id="257" r:id="R3217a6bb0fd84e2f"/>
+    <p:sldId xmlns:r="http://schemas.openxmlformats.org/officeDocument/2006/relationships" id="258" r:id="R5ab9a5e244604d1b"/>
+    <p:sldId xmlns:r="http://schemas.openxmlformats.org/officeDocument/2006/relationships" id="259" r:id="R0dc192e2f2f043d1"/>
+    <p:sldId xmlns:r="http://schemas.openxmlformats.org/officeDocument/2006/relationships" id="260" r:id="R06d2e527df5f4334"/>
+    <p:sldId xmlns:r="http://schemas.openxmlformats.org/officeDocument/2006/relationships" id="261" r:id="Ra8b809b869724dfe"/>
+    <p:sldId xmlns:r="http://schemas.openxmlformats.org/officeDocument/2006/relationships" id="262" r:id="R126959d890c14ab9"/>
+    <p:sldId xmlns:r="http://schemas.openxmlformats.org/officeDocument/2006/relationships" id="263" r:id="Rbc27af4dea4e4ee1"/>
+    <p:sldId xmlns:r="http://schemas.openxmlformats.org/officeDocument/2006/relationships" id="264" r:id="Rba1416d97ff440a3"/>
+    <p:sldId xmlns:r="http://schemas.openxmlformats.org/officeDocument/2006/relationships" id="265" r:id="R83b26c57d1c7409c"/>
+    <p:sldId xmlns:r="http://schemas.openxmlformats.org/officeDocument/2006/relationships" id="266" r:id="R374c968d21704bfb"/>
+    <p:sldId xmlns:r="http://schemas.openxmlformats.org/officeDocument/2006/relationships" id="267" r:id="R0e69c0ed0b5449cc"/>
+    <p:sldId xmlns:r="http://schemas.openxmlformats.org/officeDocument/2006/relationships" id="268" r:id="R4095b1c7a0f040e2"/>
+    <p:sldId xmlns:r="http://schemas.openxmlformats.org/officeDocument/2006/relationships" id="269" r:id="R0af296ee484049e8"/>
+    <p:sldId xmlns:r="http://schemas.openxmlformats.org/officeDocument/2006/relationships" id="270" r:id="Rbce3741a55f24dbb"/>
   </p:sldIdLst>
   <p:sldSz cx="9144000" cy="5143500"/>
   <p:notesSz cx="6858000" cy="9144000"/>
@@ -577,7 +577,7 @@
           <a:lstStyle xmlns:a="http://schemas.openxmlformats.org/drawingml/2006/main"/>
           <a:p xmlns:a="http://schemas.openxmlformats.org/drawingml/2006/main">
             <a:r>
-              <a:t>本页把“当前 replay 的证据”和“论文里的正式显著性声明”分开。当前使用 paired held-out delta、95% CI、non-loss rate 和 fold stability；这支持稳定性判断，但还不是对多条路线的完整显著性检验。论文 confirm run 将使用 paired permutation test、Benjamini-Hochberg FDR、paired bootstrap CI，并在正式运行前为各任务定义 MDE。</a:t>
+              <a:t>本页把“当前 replay 的证据”和“论文里的正式显著性声明”分开。当前使用 paired held-out delta、paired bootstrap 95% CI、non-loss rate 和 fold stability；这支持稳定性判断，但还不是对多条路线的完整显著性检验。论文 confirm run 将使用 paired permutation test、Benjamini-Hochberg FDR，并在正式运行前为各任务定义 MDE。</a:t>
             </a:r>
           </a:p>
           <a:p xmlns:a="http://schemas.openxmlformats.org/drawingml/2006/main">
@@ -592,12 +592,17 @@
           </a:p>
           <a:p xmlns:a="http://schemas.openxmlformats.org/drawingml/2006/main">
             <a:r>
-              <a:t>- Wasserstein &amp; Lazar (2016), DOI: 10.1080/00031305.2016.1154108</a:t>
+              <a:t>- Efron &amp; Tibshirani (1993), An Introduction to the Bootstrap, Chapman &amp; Hall</a:t>
             </a:r>
           </a:p>
           <a:p xmlns:a="http://schemas.openxmlformats.org/drawingml/2006/main">
             <a:r>
               <a:t>- Benjamini &amp; Hochberg (1995), DOI: 10.1111/j.2517-6161.1995.tb02031.x</a:t>
+            </a:r>
+          </a:p>
+          <a:p xmlns:a="http://schemas.openxmlformats.org/drawingml/2006/main">
+            <a:r>
+              <a:t>- Lakens (2013), DOI: 10.3389/fpsyg.2013.00863</a:t>
             </a:r>
           </a:p>
           <a:p xmlns:a="http://schemas.openxmlformats.org/drawingml/2006/main">
@@ -672,7 +677,7 @@
           <a:lstStyle xmlns:a="http://schemas.openxmlformats.org/drawingml/2006/main"/>
           <a:p xmlns:a="http://schemas.openxmlformats.org/drawingml/2006/main">
             <a:r>
-              <a:t>Gate 的目标是 route eligibility，不是统计显著性检验。当前是二态选择器：六项条件同时相对于 matched LLM 和 strongest target-only BO 成立，才部署 LLM transfer router；否则精确执行 matched target-only。0.60、0.80 和 0.25 是 calibration replay 固定下来的经验默认值，需要在 confirm run 做 threshold sweep 与 bootstrap 稳健性分析；它们不是直接从文献搬来的普适常数。</a:t>
+              <a:t>Gate 的目标是 route eligibility，不是统计显著性检验。当前只有两种实际输出：六项条件同时相对于 matched LLM 和 strongest target-only BO 成立，才部署 LLM transfer router；否则精确执行 matched target-only。0.60、0.80 和 0.25 是 calibration replay 固定下来的经验默认值，需要在 confirm run 做 threshold sweep 与 bootstrap 稳健性分析；它们不是直接从文献搬来的普适常数。Hold 只是下一版计划中的第三种状态，当前代码未启用。</a:t>
             </a:r>
           </a:p>
           <a:p xmlns:a="http://schemas.openxmlformats.org/drawingml/2006/main">
@@ -767,10 +772,14 @@
           <a:lstStyle xmlns:a="http://schemas.openxmlformats.org/drawingml/2006/main"/>
           <a:p xmlns:a="http://schemas.openxmlformats.org/drawingml/2006/main">
             <a:r>
-              <a:t>这页区分了已经完整覆盖的对照与仍需补跑的主论文实验。No-transfer 与 Full framework 已在正式七路线中完成；without gate 的代码存在，但要在全部七路线和同一 seed split 上重跑；random-transfer、similarity-only 和 without hypothesis validation 目前只有历史或局部结果，不能写成完整结论。最终所有方法必须使用相同 target budget、initial observations 和 held-out seeds。</a:t>
-            </a:r>
-          </a:p>
-          <a:p xmlns:a="http://schemas.openxmlformats.org/drawingml/2006/main"/>
+              <a:t>本页补上了红字要求的 baseline 实际结果，而不再只列完成状态。相对 matched target-only LLM，四条路线部署 transfer 且全部为正，三条路线精确回退，因此是 4/7 正向、3/7 为零、0 条负向部署；相对每个任务最强 target-only BO，完整部署系统 7/7 的 final-best delta 为正。raw source route 若取消 Gate，ESOL 到 Lipophilicity 与 Lipophilicity 到 FreeSolv 显著负迁移，Phonons 到 dielectric 的区间跨零。Random-transfer 与 similarity/no-validation 仍只有局部覆盖，因此明确标为 PARTIAL。</a:t>
+            </a:r>
+          </a:p>
+          <a:p xmlns:a="http://schemas.openxmlformats.org/drawingml/2006/main">
+            <a:r>
+              <a:t/>
+            </a:r>
+          </a:p>
           <a:p xmlns:a="http://schemas.openxmlformats.org/drawingml/2006/main">
             <a:r>
               <a:t>[Sources]</a:t>
@@ -778,12 +787,17 @@
           </a:p>
           <a:p xmlns:a="http://schemas.openxmlformats.org/drawingml/2006/main">
             <a:r>
+              <a:t>- CARE2.0 baseline_comparison.csv (2026-07-28)</a:t>
+            </a:r>
+          </a:p>
+          <a:p xmlns:a="http://schemas.openxmlformats.org/drawingml/2006/main">
+            <a:r>
               <a:t>- CARE2.0 baseline_protocol_coverage.csv (2026-07-28)</a:t>
             </a:r>
           </a:p>
           <a:p xmlns:a="http://schemas.openxmlformats.org/drawingml/2006/main">
             <a:r>
-              <a:t>- CARE2.0 baseline_protocol_matrix.png (2026-07-28)</a:t>
+              <a:t>- CARE2.0 source-outcome transfer frozen archive (2026-07-24)</a:t>
             </a:r>
           </a:p>
         </p:txBody>
@@ -853,10 +867,14 @@
           <a:lstStyle xmlns:a="http://schemas.openxmlformats.org/drawingml/2006/main"/>
           <a:p xmlns:a="http://schemas.openxmlformats.org/drawingml/2006/main">
             <a:r>
-              <a:t>图 A 是达到 matched LLM 最终质量所节省的 target acquisitions，图 B 是达到全局 top-10 所节省的轮数，图 C 是不同预算点的 best-so-far delta。四条部署路线都节省轮数。关于边际收益递减，目前只能说早期 delta 往往高于 final delta；要证明随经验条目或迁移次数增加而饱和，需要专门横轴、误差线和拟合检验。</a:t>
-            </a:r>
-          </a:p>
-          <a:p xmlns:a="http://schemas.openxmlformats.org/drawingml/2006/main"/>
+              <a:t>右侧第一行报告达到 matched target-only LLM 最终质量所节省的平均轮数，括号内是同一 held-out seed 配对得到的 95% CI；第二行补充提前命中全局 top-10 候选所节省的平均轮数。四条部署路线的 matched-final round-saving 区间均不跨零。这里不再把“早期增益更大”直接解释为边际收益递减；饱和结论需要在不同 source-history size 下重新运行。</a:t>
+            </a:r>
+          </a:p>
+          <a:p xmlns:a="http://schemas.openxmlformats.org/drawingml/2006/main">
+            <a:r>
+              <a:t/>
+            </a:r>
+          </a:p>
           <a:p xmlns:a="http://schemas.openxmlformats.org/drawingml/2006/main">
             <a:r>
               <a:t>[Sources]</a:t>
@@ -864,7 +882,12 @@
           </a:p>
           <a:p xmlns:a="http://schemas.openxmlformats.org/drawingml/2006/main">
             <a:r>
-              <a:t>- CARE2.0 iteration_efficiency.png and iteration_efficiency.csv (2026-07-28)</a:t>
+              <a:t>- CARE2.0 iteration_efficiency.csv (2026-07-28)</a:t>
+            </a:r>
+          </a:p>
+          <a:p xmlns:a="http://schemas.openxmlformats.org/drawingml/2006/main">
+            <a:r>
+              <a:t>- CARE2.0 build_20260728_evaluation_completion.py</a:t>
             </a:r>
           </a:p>
         </p:txBody>
@@ -1818,7 +1841,7 @@
   </p:cSld>
   <p:clrMap bg1="lt1" tx1="dk1" bg2="lt2" tx2="dk2" accent1="accent1" accent2="accent2" accent3="accent3" accent4="accent4" accent5="accent5" accent6="accent6" hlink="hlink" folHlink="folHlink"/>
   <p:sldLayoutIdLst>
-    <p:sldLayoutId xmlns:r="http://schemas.openxmlformats.org/officeDocument/2006/relationships" id="2147483649" r:id="Rce194dbe7fdc4c39"/>
+    <p:sldLayoutId xmlns:r="http://schemas.openxmlformats.org/officeDocument/2006/relationships" id="2147483649" r:id="R9fddbb4558d746a6"/>
   </p:sldLayoutIdLst>
   <p:hf sldNum="0" hdr="0" ftr="0" dt="0"/>
   <p:txStyles>
@@ -2386,7 +2409,7 @@
           <p:nvPr/>
         </p:nvPicPr>
         <p:blipFill>
-          <a:blip xmlns:r="http://schemas.openxmlformats.org/officeDocument/2006/relationships" xmlns:a="http://schemas.openxmlformats.org/drawingml/2006/main" r:embed="R51370d442a764b47"/>
+          <a:blip xmlns:r="http://schemas.openxmlformats.org/officeDocument/2006/relationships" xmlns:a="http://schemas.openxmlformats.org/drawingml/2006/main" r:embed="Rbe57fcd51c21463b"/>
           <a:stretch xmlns:a="http://schemas.openxmlformats.org/drawingml/2006/main">
             <a:fillRect l="0" t="0" r="0" b="0"/>
           </a:stretch>
@@ -2624,7 +2647,7 @@
           <p:nvPr/>
         </p:nvPicPr>
         <p:blipFill>
-          <a:blip xmlns:r="http://schemas.openxmlformats.org/officeDocument/2006/relationships" xmlns:a="http://schemas.openxmlformats.org/drawingml/2006/main" r:embed="R83c420bae5e444ee"/>
+          <a:blip xmlns:r="http://schemas.openxmlformats.org/officeDocument/2006/relationships" xmlns:a="http://schemas.openxmlformats.org/drawingml/2006/main" r:embed="Rf34efca9981d4751"/>
           <a:stretch xmlns:a="http://schemas.openxmlformats.org/drawingml/2006/main">
             <a:fillRect l="0" t="0" r="0" b="0"/>
           </a:stretch>
@@ -2940,7 +2963,7 @@
           <p:nvPr/>
         </p:nvPicPr>
         <p:blipFill>
-          <a:blip xmlns:r="http://schemas.openxmlformats.org/officeDocument/2006/relationships" xmlns:a="http://schemas.openxmlformats.org/drawingml/2006/main" r:embed="R42ed695502fc4117"/>
+          <a:blip xmlns:r="http://schemas.openxmlformats.org/officeDocument/2006/relationships" xmlns:a="http://schemas.openxmlformats.org/drawingml/2006/main" r:embed="Ra1b079ba33024fa0"/>
           <a:stretch xmlns:a="http://schemas.openxmlformats.org/drawingml/2006/main">
             <a:fillRect l="0" t="0" r="0" b="0"/>
           </a:stretch>
@@ -3275,7 +3298,7 @@
           <p:nvPr/>
         </p:nvPicPr>
         <p:blipFill>
-          <a:blip xmlns:r="http://schemas.openxmlformats.org/officeDocument/2006/relationships" xmlns:a="http://schemas.openxmlformats.org/drawingml/2006/main" r:embed="Rc44f87225a6a4db2"/>
+          <a:blip xmlns:r="http://schemas.openxmlformats.org/officeDocument/2006/relationships" xmlns:a="http://schemas.openxmlformats.org/drawingml/2006/main" r:embed="R5e0522b7f03248d2"/>
           <a:stretch xmlns:a="http://schemas.openxmlformats.org/drawingml/2006/main">
             <a:fillRect l="0" t="0" r="0" b="0"/>
           </a:stretch>
@@ -3527,7 +3550,7 @@
           <p:nvPr/>
         </p:nvPicPr>
         <p:blipFill>
-          <a:blip xmlns:r="http://schemas.openxmlformats.org/officeDocument/2006/relationships" xmlns:a="http://schemas.openxmlformats.org/drawingml/2006/main" r:embed="Rc44f87225a6a4db2"/>
+          <a:blip xmlns:r="http://schemas.openxmlformats.org/officeDocument/2006/relationships" xmlns:a="http://schemas.openxmlformats.org/drawingml/2006/main" r:embed="R5e0522b7f03248d2"/>
           <a:stretch xmlns:a="http://schemas.openxmlformats.org/drawingml/2006/main">
             <a:fillRect l="0" t="0" r="0" b="0"/>
           </a:stretch>
@@ -4169,7 +4192,31 @@
                 <a:ea typeface="-apple-system"/>
                 <a:cs typeface="-apple-system"/>
               </a:rPr>
-              <a:t>效果可能范围；若跨 0，方向仍不稳。</a:t>
+              <a:t>paired bootstrap</a:t>
+            </a:r>
+          </a:p>
+          <a:p xmlns:a="http://schemas.openxmlformats.org/drawingml/2006/main">
+            <a:pPr algn="ctr">
+              <a:buNone/>
+              <a:defRPr sz="863" b="1">
+                <a:solidFill>
+                  <a:srgbClr val="17212B"/>
+                </a:solidFill>
+                <a:latin typeface="-apple-system"/>
+                <a:ea typeface="-apple-system"/>
+                <a:cs typeface="-apple-system"/>
+              </a:defRPr>
+            </a:pPr>
+            <a:r>
+              <a:rPr sz="863" b="1">
+                <a:solidFill>
+                  <a:srgbClr val="17212B"/>
+                </a:solidFill>
+                <a:latin typeface="-apple-system"/>
+                <a:ea typeface="-apple-system"/>
+                <a:cs typeface="-apple-system"/>
+              </a:rPr>
+              <a:t>Efron &amp; Tibshirani, 1993</a:t>
             </a:r>
           </a:p>
         </p:txBody>
@@ -4258,7 +4305,31 @@
                 <a:ea typeface="-apple-system"/>
                 <a:cs typeface="-apple-system"/>
               </a:rPr>
-              <a:t>多路线比较后仍达标的统计证据。</a:t>
+              <a:t>BH-FDR</a:t>
+            </a:r>
+          </a:p>
+          <a:p xmlns:a="http://schemas.openxmlformats.org/drawingml/2006/main">
+            <a:pPr algn="ctr">
+              <a:buNone/>
+              <a:defRPr sz="863" b="1">
+                <a:solidFill>
+                  <a:srgbClr val="17212B"/>
+                </a:solidFill>
+                <a:latin typeface="-apple-system"/>
+                <a:ea typeface="-apple-system"/>
+                <a:cs typeface="-apple-system"/>
+              </a:defRPr>
+            </a:pPr>
+            <a:r>
+              <a:rPr sz="863" b="1">
+                <a:solidFill>
+                  <a:srgbClr val="17212B"/>
+                </a:solidFill>
+                <a:latin typeface="-apple-system"/>
+                <a:ea typeface="-apple-system"/>
+                <a:cs typeface="-apple-system"/>
+              </a:rPr>
+              <a:t>Benjamini &amp; Hochberg, 1995</a:t>
             </a:r>
           </a:p>
         </p:txBody>
@@ -4299,17 +4370,79 @@
         </p:spPr>
         <p:txBody>
           <a:bodyPr xmlns:a="http://schemas.openxmlformats.org/drawingml/2006/main" wrap="square" lIns="114300" tIns="95250" rIns="114300" bIns="95250" anchor="ctr">
-            <a:normAutofit fontScale="60747"/>
-          </a:bodyPr>
-          <a:lstStyle xmlns:a="http://schemas.openxmlformats.org/drawingml/2006/main"/>
-          <a:p xmlns:a="http://schemas.openxmlformats.org/drawingml/2006/main">
-            <a:r>
+            <a:normAutofit fontScale="100000"/>
+          </a:bodyPr>
+          <a:lstStyle xmlns:a="http://schemas.openxmlformats.org/drawingml/2006/main"/>
+          <a:p xmlns:a="http://schemas.openxmlformats.org/drawingml/2006/main">
+            <a:pPr algn="ctr">
+              <a:buNone/>
+              <a:defRPr sz="863" b="1">
+                <a:solidFill>
+                  <a:srgbClr val="17212B"/>
+                </a:solidFill>
+                <a:latin typeface="-apple-system"/>
+                <a:ea typeface="-apple-system"/>
+                <a:cs typeface="-apple-system"/>
+              </a:defRPr>
+            </a:pPr>
+            <a:r>
+              <a:rPr sz="863" b="1">
+                <a:solidFill>
+                  <a:srgbClr val="17212B"/>
+                </a:solidFill>
+                <a:latin typeface="-apple-system"/>
+                <a:ea typeface="-apple-system"/>
+                <a:cs typeface="-apple-system"/>
+              </a:rPr>
               <a:t>MDE</a:t>
             </a:r>
           </a:p>
           <a:p xmlns:a="http://schemas.openxmlformats.org/drawingml/2006/main">
-            <a:r>
-              <a:t>任务上真正有价值的最小效果；需在 confirm run 前定义。</a:t>
+            <a:pPr algn="ctr">
+              <a:buNone/>
+              <a:defRPr sz="863" b="1">
+                <a:solidFill>
+                  <a:srgbClr val="17212B"/>
+                </a:solidFill>
+                <a:latin typeface="-apple-system"/>
+                <a:ea typeface="-apple-system"/>
+                <a:cs typeface="-apple-system"/>
+              </a:defRPr>
+            </a:pPr>
+            <a:r>
+              <a:rPr sz="863" b="1">
+                <a:solidFill>
+                  <a:srgbClr val="17212B"/>
+                </a:solidFill>
+                <a:latin typeface="-apple-system"/>
+                <a:ea typeface="-apple-system"/>
+                <a:cs typeface="-apple-system"/>
+              </a:rPr>
+              <a:t>practical effect</a:t>
+            </a:r>
+          </a:p>
+          <a:p xmlns:a="http://schemas.openxmlformats.org/drawingml/2006/main">
+            <a:pPr algn="ctr">
+              <a:buNone/>
+              <a:defRPr sz="863" b="1">
+                <a:solidFill>
+                  <a:srgbClr val="17212B"/>
+                </a:solidFill>
+                <a:latin typeface="-apple-system"/>
+                <a:ea typeface="-apple-system"/>
+                <a:cs typeface="-apple-system"/>
+              </a:defRPr>
+            </a:pPr>
+            <a:r>
+              <a:rPr sz="863" b="1">
+                <a:solidFill>
+                  <a:srgbClr val="17212B"/>
+                </a:solidFill>
+                <a:latin typeface="-apple-system"/>
+                <a:ea typeface="-apple-system"/>
+                <a:cs typeface="-apple-system"/>
+              </a:rPr>
+              <a:t>Lakens, 2013</a:t>
             </a:r>
           </a:p>
         </p:txBody>
@@ -4345,7 +4478,7 @@
           <p:nvPr/>
         </p:nvPicPr>
         <p:blipFill>
-          <a:blip xmlns:r="http://schemas.openxmlformats.org/officeDocument/2006/relationships" xmlns:a="http://schemas.openxmlformats.org/drawingml/2006/main" r:embed="Rd8d894aa88404db6"/>
+          <a:blip xmlns:r="http://schemas.openxmlformats.org/officeDocument/2006/relationships" xmlns:a="http://schemas.openxmlformats.org/drawingml/2006/main" r:embed="Re474437ffee34c31"/>
           <a:stretch xmlns:a="http://schemas.openxmlformats.org/drawingml/2006/main">
             <a:fillRect l="0" t="0" r="0" b="0"/>
           </a:stretch>
@@ -4513,7 +4646,7 @@
           <p:nvPr/>
         </p:nvPicPr>
         <p:blipFill>
-          <a:blip xmlns:r="http://schemas.openxmlformats.org/officeDocument/2006/relationships" xmlns:a="http://schemas.openxmlformats.org/drawingml/2006/main" r:embed="R7e65cc615f9f4522"/>
+          <a:blip xmlns:r="http://schemas.openxmlformats.org/officeDocument/2006/relationships" xmlns:a="http://schemas.openxmlformats.org/drawingml/2006/main" r:embed="Ra4678c727fc64a29"/>
           <a:stretch xmlns:a="http://schemas.openxmlformats.org/drawingml/2006/main">
             <a:fillRect l="0" t="0" r="0" b="0"/>
           </a:stretch>
@@ -4537,7 +4670,7 @@
           <p:nvPr/>
         </p:nvPicPr>
         <p:blipFill>
-          <a:blip xmlns:r="http://schemas.openxmlformats.org/officeDocument/2006/relationships" xmlns:a="http://schemas.openxmlformats.org/drawingml/2006/main" r:embed="R0901cb587e604eb3"/>
+          <a:blip xmlns:r="http://schemas.openxmlformats.org/officeDocument/2006/relationships" xmlns:a="http://schemas.openxmlformats.org/drawingml/2006/main" r:embed="Rd9ac94b820404dfe"/>
           <a:stretch xmlns:a="http://schemas.openxmlformats.org/drawingml/2006/main">
             <a:fillRect l="0" t="0" r="0" b="0"/>
           </a:stretch>
@@ -4712,7 +4845,7 @@
           <p:nvPr/>
         </p:nvPicPr>
         <p:blipFill>
-          <a:blip xmlns:r="http://schemas.openxmlformats.org/officeDocument/2006/relationships" xmlns:a="http://schemas.openxmlformats.org/drawingml/2006/main" r:embed="R2ffa8484f1814a20"/>
+          <a:blip xmlns:r="http://schemas.openxmlformats.org/officeDocument/2006/relationships" xmlns:a="http://schemas.openxmlformats.org/drawingml/2006/main" r:embed="Ra5e455e9861f4bc8"/>
           <a:stretch xmlns:a="http://schemas.openxmlformats.org/drawingml/2006/main">
             <a:fillRect l="0" t="0" r="0" b="0"/>
           </a:stretch>
@@ -4810,7 +4943,7 @@
           <p:nvPr/>
         </p:nvPicPr>
         <p:blipFill>
-          <a:blip xmlns:r="http://schemas.openxmlformats.org/officeDocument/2006/relationships" xmlns:a="http://schemas.openxmlformats.org/drawingml/2006/main" r:embed="R41281e66dd024a05"/>
+          <a:blip xmlns:r="http://schemas.openxmlformats.org/officeDocument/2006/relationships" xmlns:a="http://schemas.openxmlformats.org/drawingml/2006/main" r:embed="Re059832d96e14bb7"/>
           <a:stretch xmlns:a="http://schemas.openxmlformats.org/drawingml/2006/main">
             <a:fillRect l="0" t="0" r="0" b="0"/>
           </a:stretch>
@@ -4908,7 +5041,7 @@
           <p:nvPr/>
         </p:nvPicPr>
         <p:blipFill>
-          <a:blip xmlns:r="http://schemas.openxmlformats.org/officeDocument/2006/relationships" xmlns:a="http://schemas.openxmlformats.org/drawingml/2006/main" r:embed="R69e6fa0c07184f3d"/>
+          <a:blip xmlns:r="http://schemas.openxmlformats.org/officeDocument/2006/relationships" xmlns:a="http://schemas.openxmlformats.org/drawingml/2006/main" r:embed="R629a52bb0ade458f"/>
           <a:stretch xmlns:a="http://schemas.openxmlformats.org/drawingml/2006/main">
             <a:fillRect l="0" t="0" r="0" b="0"/>
           </a:stretch>
@@ -5006,7 +5139,7 @@
           <p:nvPr/>
         </p:nvPicPr>
         <p:blipFill>
-          <a:blip xmlns:r="http://schemas.openxmlformats.org/officeDocument/2006/relationships" xmlns:a="http://schemas.openxmlformats.org/drawingml/2006/main" r:embed="R41281e66dd024a05"/>
+          <a:blip xmlns:r="http://schemas.openxmlformats.org/officeDocument/2006/relationships" xmlns:a="http://schemas.openxmlformats.org/drawingml/2006/main" r:embed="Re059832d96e14bb7"/>
           <a:stretch xmlns:a="http://schemas.openxmlformats.org/drawingml/2006/main">
             <a:fillRect l="0" t="0" r="0" b="0"/>
           </a:stretch>
@@ -5104,7 +5237,7 @@
           <p:nvPr/>
         </p:nvPicPr>
         <p:blipFill>
-          <a:blip xmlns:r="http://schemas.openxmlformats.org/officeDocument/2006/relationships" xmlns:a="http://schemas.openxmlformats.org/drawingml/2006/main" r:embed="R69e6fa0c07184f3d"/>
+          <a:blip xmlns:r="http://schemas.openxmlformats.org/officeDocument/2006/relationships" xmlns:a="http://schemas.openxmlformats.org/drawingml/2006/main" r:embed="R629a52bb0ade458f"/>
           <a:stretch xmlns:a="http://schemas.openxmlformats.org/drawingml/2006/main">
             <a:fillRect l="0" t="0" r="0" b="0"/>
           </a:stretch>
@@ -5202,7 +5335,7 @@
           <p:nvPr/>
         </p:nvPicPr>
         <p:blipFill>
-          <a:blip xmlns:r="http://schemas.openxmlformats.org/officeDocument/2006/relationships" xmlns:a="http://schemas.openxmlformats.org/drawingml/2006/main" r:embed="R41281e66dd024a05"/>
+          <a:blip xmlns:r="http://schemas.openxmlformats.org/officeDocument/2006/relationships" xmlns:a="http://schemas.openxmlformats.org/drawingml/2006/main" r:embed="Re059832d96e14bb7"/>
           <a:stretch xmlns:a="http://schemas.openxmlformats.org/drawingml/2006/main">
             <a:fillRect l="0" t="0" r="0" b="0"/>
           </a:stretch>
@@ -5300,7 +5433,7 @@
           <p:nvPr/>
         </p:nvPicPr>
         <p:blipFill>
-          <a:blip xmlns:r="http://schemas.openxmlformats.org/officeDocument/2006/relationships" xmlns:a="http://schemas.openxmlformats.org/drawingml/2006/main" r:embed="R69e6fa0c07184f3d"/>
+          <a:blip xmlns:r="http://schemas.openxmlformats.org/officeDocument/2006/relationships" xmlns:a="http://schemas.openxmlformats.org/drawingml/2006/main" r:embed="R629a52bb0ade458f"/>
           <a:stretch xmlns:a="http://schemas.openxmlformats.org/drawingml/2006/main">
             <a:fillRect l="0" t="0" r="0" b="0"/>
           </a:stretch>
@@ -5490,7 +5623,7 @@
         </p:spPr>
         <p:txBody>
           <a:bodyPr xmlns:a="http://schemas.openxmlformats.org/drawingml/2006/main" wrap="square" lIns="0" tIns="0" rIns="0" bIns="0" anchor="t">
-            <a:normAutofit fontScale="92602"/>
+            <a:normAutofit fontScale="88894"/>
           </a:bodyPr>
           <a:lstStyle xmlns:a="http://schemas.openxmlformats.org/drawingml/2006/main"/>
           <a:p xmlns:a="http://schemas.openxmlformats.org/drawingml/2006/main">
@@ -5514,7 +5647,7 @@
                 <a:ea typeface="-apple-system"/>
                 <a:cs typeface="-apple-system"/>
               </a:rPr>
-              <a:t>二态 Gate：六项全过 = Transfer；否则 = Freeze（精确回退到 target-only）</a:t>
+              <a:t>Gate 只有两种输出：六项全过则 Transfer；否则 Freeze 并精确回退 target-only</a:t>
             </a:r>
           </a:p>
         </p:txBody>
@@ -6419,7 +6552,7 @@
                 <a:ea typeface="-apple-system"/>
                 <a:cs typeface="-apple-system"/>
               </a:rPr>
-              <a:t>Hold 是下一版的“证据不足、追加 calibration”状态；不属于当前二态部署。</a:t>
+              <a:t>Hold 是下一版本候选的第三种状态；当前版本没有 Hold。</a:t>
             </a:r>
           </a:p>
         </p:txBody>
@@ -6455,7 +6588,7 @@
           <p:nvPr/>
         </p:nvPicPr>
         <p:blipFill>
-          <a:blip xmlns:r="http://schemas.openxmlformats.org/officeDocument/2006/relationships" xmlns:a="http://schemas.openxmlformats.org/drawingml/2006/main" r:embed="Ra819a31fc4a74a32"/>
+          <a:blip xmlns:r="http://schemas.openxmlformats.org/officeDocument/2006/relationships" xmlns:a="http://schemas.openxmlformats.org/drawingml/2006/main" r:embed="Rb5688e8a6e424255"/>
           <a:stretch xmlns:a="http://schemas.openxmlformats.org/drawingml/2006/main">
             <a:fillRect l="0" t="0" r="0" b="0"/>
           </a:stretch>
@@ -6562,7 +6695,7 @@
                 <a:ea typeface="-apple-system"/>
                 <a:cs typeface="-apple-system"/>
               </a:rPr>
-              <a:t>每个模块都要用 matched-budget baseline 或 ablation 单独证明</a:t>
+              <a:t>完整系统：4/7 超过 matched LLM，3/7 精确回退；7/7 超过 strongest BO</a:t>
             </a:r>
           </a:p>
         </p:txBody>
@@ -6691,7 +6824,7 @@
           <p:nvPr/>
         </p:nvPicPr>
         <p:blipFill>
-          <a:blip xmlns:r="http://schemas.openxmlformats.org/officeDocument/2006/relationships" xmlns:a="http://schemas.openxmlformats.org/drawingml/2006/main" r:embed="R91b5dd9c2cb54ad1"/>
+          <a:blip xmlns:r="http://schemas.openxmlformats.org/officeDocument/2006/relationships" xmlns:a="http://schemas.openxmlformats.org/drawingml/2006/main" r:embed="R353be5c024ca4b43"/>
           <a:stretch xmlns:a="http://schemas.openxmlformats.org/drawingml/2006/main">
             <a:fillRect l="0" t="0" r="0" b="0"/>
           </a:stretch>
@@ -7053,7 +7186,7 @@
           <p:nvPr/>
         </p:nvPicPr>
         <p:blipFill>
-          <a:blip xmlns:r="http://schemas.openxmlformats.org/officeDocument/2006/relationships" xmlns:a="http://schemas.openxmlformats.org/drawingml/2006/main" r:embed="R914827522ae94769"/>
+          <a:blip xmlns:r="http://schemas.openxmlformats.org/officeDocument/2006/relationships" xmlns:a="http://schemas.openxmlformats.org/drawingml/2006/main" r:embed="Re8393bcdcc6c4118"/>
           <a:stretch xmlns:a="http://schemas.openxmlformats.org/drawingml/2006/main">
             <a:fillRect l="0" t="0" r="0" b="0"/>
           </a:stretch>
@@ -7249,7 +7382,7 @@
           <p:nvPr/>
         </p:nvPicPr>
         <p:blipFill>
-          <a:blip xmlns:r="http://schemas.openxmlformats.org/officeDocument/2006/relationships" xmlns:a="http://schemas.openxmlformats.org/drawingml/2006/main" r:embed="R914827522ae94769"/>
+          <a:blip xmlns:r="http://schemas.openxmlformats.org/officeDocument/2006/relationships" xmlns:a="http://schemas.openxmlformats.org/drawingml/2006/main" r:embed="Re8393bcdcc6c4118"/>
           <a:stretch xmlns:a="http://schemas.openxmlformats.org/drawingml/2006/main">
             <a:fillRect l="0" t="0" r="0" b="0"/>
           </a:stretch>
@@ -7316,7 +7449,7 @@
           <p:nvPr/>
         </p:nvPicPr>
         <p:blipFill>
-          <a:blip xmlns:r="http://schemas.openxmlformats.org/officeDocument/2006/relationships" xmlns:a="http://schemas.openxmlformats.org/drawingml/2006/main" r:embed="R914827522ae94769"/>
+          <a:blip xmlns:r="http://schemas.openxmlformats.org/officeDocument/2006/relationships" xmlns:a="http://schemas.openxmlformats.org/drawingml/2006/main" r:embed="Re8393bcdcc6c4118"/>
           <a:stretch xmlns:a="http://schemas.openxmlformats.org/drawingml/2006/main">
             <a:fillRect l="0" t="0" r="0" b="0"/>
           </a:stretch>
@@ -7638,7 +7771,7 @@
           <p:nvPr/>
         </p:nvPicPr>
         <p:blipFill>
-          <a:blip xmlns:r="http://schemas.openxmlformats.org/officeDocument/2006/relationships" xmlns:a="http://schemas.openxmlformats.org/drawingml/2006/main" r:embed="R914827522ae94769"/>
+          <a:blip xmlns:r="http://schemas.openxmlformats.org/officeDocument/2006/relationships" xmlns:a="http://schemas.openxmlformats.org/drawingml/2006/main" r:embed="Re8393bcdcc6c4118"/>
           <a:stretch xmlns:a="http://schemas.openxmlformats.org/drawingml/2006/main">
             <a:fillRect l="0" t="0" r="0" b="0"/>
           </a:stretch>
@@ -7705,7 +7838,7 @@
           <p:nvPr/>
         </p:nvPicPr>
         <p:blipFill>
-          <a:blip xmlns:r="http://schemas.openxmlformats.org/officeDocument/2006/relationships" xmlns:a="http://schemas.openxmlformats.org/drawingml/2006/main" r:embed="R4b051d6591774668"/>
+          <a:blip xmlns:r="http://schemas.openxmlformats.org/officeDocument/2006/relationships" xmlns:a="http://schemas.openxmlformats.org/drawingml/2006/main" r:embed="R55befd13bfbf47a3"/>
           <a:stretch xmlns:a="http://schemas.openxmlformats.org/drawingml/2006/main">
             <a:fillRect l="0" t="0" r="0" b="0"/>
           </a:stretch>
@@ -8163,7 +8296,7 @@
         </p:spPr>
         <p:txBody>
           <a:bodyPr xmlns:a="http://schemas.openxmlformats.org/drawingml/2006/main" wrap="square" lIns="76200" tIns="66675" rIns="76200" bIns="66675" anchor="ctr">
-            <a:normAutofit/>
+            <a:normAutofit fontScale="100000"/>
           </a:bodyPr>
           <a:lstStyle xmlns:a="http://schemas.openxmlformats.org/drawingml/2006/main"/>
           <a:p xmlns:a="http://schemas.openxmlformats.org/drawingml/2006/main">
@@ -8187,7 +8320,7 @@
                 <a:ea typeface="-apple-system"/>
                 <a:cs typeface="-apple-system"/>
               </a:rPr>
-              <a:t>No-transfer</a:t>
+              <a:t>Target-only LLM</a:t>
             </a:r>
           </a:p>
         </p:txBody>
@@ -8226,7 +8359,7 @@
         </p:spPr>
         <p:txBody>
           <a:bodyPr xmlns:a="http://schemas.openxmlformats.org/drawingml/2006/main" wrap="square" lIns="76200" tIns="66675" rIns="76200" bIns="66675" anchor="ctr">
-            <a:normAutofit/>
+            <a:normAutofit fontScale="100000"/>
           </a:bodyPr>
           <a:lstStyle xmlns:a="http://schemas.openxmlformats.org/drawingml/2006/main"/>
           <a:p xmlns:a="http://schemas.openxmlformats.org/drawingml/2006/main">
@@ -8250,7 +8383,7 @@
                 <a:ea typeface="-apple-system"/>
                 <a:cs typeface="-apple-system"/>
               </a:rPr>
-              <a:t>matched target-only LLM / strong BO</a:t>
+              <a:t>same target budget + seeds</a:t>
             </a:r>
           </a:p>
         </p:txBody>
@@ -8289,7 +8422,7 @@
         </p:spPr>
         <p:txBody>
           <a:bodyPr xmlns:a="http://schemas.openxmlformats.org/drawingml/2006/main" wrap="square" lIns="76200" tIns="66675" rIns="76200" bIns="66675" anchor="ctr">
-            <a:normAutofit/>
+            <a:normAutofit fontScale="100000"/>
           </a:bodyPr>
           <a:lstStyle xmlns:a="http://schemas.openxmlformats.org/drawingml/2006/main"/>
           <a:p xmlns:a="http://schemas.openxmlformats.org/drawingml/2006/main">
@@ -8313,7 +8446,7 @@
                 <a:ea typeface="-apple-system"/>
                 <a:cs typeface="-apple-system"/>
               </a:rPr>
-              <a:t>隔离 source evidence</a:t>
+              <a:t>隔离 source-outcome 净增益</a:t>
             </a:r>
           </a:p>
         </p:txBody>
@@ -8352,7 +8485,7 @@
         </p:spPr>
         <p:txBody>
           <a:bodyPr xmlns:a="http://schemas.openxmlformats.org/drawingml/2006/main" wrap="square" lIns="76200" tIns="66675" rIns="76200" bIns="66675" anchor="ctr">
-            <a:normAutofit/>
+            <a:normAutofit fontScale="100000"/>
           </a:bodyPr>
           <a:lstStyle xmlns:a="http://schemas.openxmlformats.org/drawingml/2006/main"/>
           <a:p xmlns:a="http://schemas.openxmlformats.org/drawingml/2006/main">
@@ -8376,7 +8509,7 @@
                 <a:ea typeface="-apple-system"/>
                 <a:cs typeface="-apple-system"/>
               </a:rPr>
-              <a:t>COMPLETE</a:t>
+              <a:t>4/7 ↑ · 3/7 =</a:t>
             </a:r>
           </a:p>
         </p:txBody>
@@ -8415,7 +8548,7 @@
         </p:spPr>
         <p:txBody>
           <a:bodyPr xmlns:a="http://schemas.openxmlformats.org/drawingml/2006/main" wrap="square" lIns="76200" tIns="66675" rIns="76200" bIns="66675" anchor="ctr">
-            <a:normAutofit/>
+            <a:normAutofit fontScale="100000"/>
           </a:bodyPr>
           <a:lstStyle xmlns:a="http://schemas.openxmlformats.org/drawingml/2006/main"/>
           <a:p xmlns:a="http://schemas.openxmlformats.org/drawingml/2006/main">
@@ -8439,7 +8572,7 @@
                 <a:ea typeface="-apple-system"/>
                 <a:cs typeface="-apple-system"/>
               </a:rPr>
-              <a:t>Random-transfer</a:t>
+              <a:t>Strongest target BO</a:t>
             </a:r>
           </a:p>
         </p:txBody>
@@ -8478,7 +8611,7 @@
         </p:spPr>
         <p:txBody>
           <a:bodyPr xmlns:a="http://schemas.openxmlformats.org/drawingml/2006/main" wrap="square" lIns="76200" tIns="66675" rIns="76200" bIns="66675" anchor="ctr">
-            <a:normAutofit/>
+            <a:normAutofit fontScale="100000"/>
           </a:bodyPr>
           <a:lstStyle xmlns:a="http://schemas.openxmlformats.org/drawingml/2006/main"/>
           <a:p xmlns:a="http://schemas.openxmlformats.org/drawingml/2006/main">
@@ -8502,7 +8635,7 @@
                 <a:ea typeface="-apple-system"/>
                 <a:cs typeface="-apple-system"/>
               </a:rPr>
-              <a:t>matched random rule</a:t>
+              <a:t>GP-UCB / GP-EI / portfolio</a:t>
             </a:r>
           </a:p>
         </p:txBody>
@@ -8541,7 +8674,7 @@
         </p:spPr>
         <p:txBody>
           <a:bodyPr xmlns:a="http://schemas.openxmlformats.org/drawingml/2006/main" wrap="square" lIns="76200" tIns="66675" rIns="76200" bIns="66675" anchor="ctr">
-            <a:normAutofit/>
+            <a:normAutofit fontScale="100000"/>
           </a:bodyPr>
           <a:lstStyle xmlns:a="http://schemas.openxmlformats.org/drawingml/2006/main"/>
           <a:p xmlns:a="http://schemas.openxmlformats.org/drawingml/2006/main">
@@ -8565,7 +8698,7 @@
                 <a:ea typeface="-apple-system"/>
                 <a:cs typeface="-apple-system"/>
               </a:rPr>
-              <a:t>排除规则形式红利</a:t>
+              <a:t>检验完整系统是否胜过强 BO</a:t>
             </a:r>
           </a:p>
         </p:txBody>
@@ -8604,7 +8737,7 @@
         </p:spPr>
         <p:txBody>
           <a:bodyPr xmlns:a="http://schemas.openxmlformats.org/drawingml/2006/main" wrap="square" lIns="76200" tIns="66675" rIns="76200" bIns="66675" anchor="ctr">
-            <a:normAutofit/>
+            <a:normAutofit fontScale="100000"/>
           </a:bodyPr>
           <a:lstStyle xmlns:a="http://schemas.openxmlformats.org/drawingml/2006/main"/>
           <a:p xmlns:a="http://schemas.openxmlformats.org/drawingml/2006/main">
@@ -8628,7 +8761,7 @@
                 <a:ea typeface="-apple-system"/>
                 <a:cs typeface="-apple-system"/>
               </a:rPr>
-              <a:t>PARTIAL</a:t>
+              <a:t>7/7 ↑</a:t>
             </a:r>
           </a:p>
         </p:txBody>
@@ -8667,7 +8800,7 @@
         </p:spPr>
         <p:txBody>
           <a:bodyPr xmlns:a="http://schemas.openxmlformats.org/drawingml/2006/main" wrap="square" lIns="76200" tIns="66675" rIns="76200" bIns="66675" anchor="ctr">
-            <a:normAutofit/>
+            <a:normAutofit fontScale="100000"/>
           </a:bodyPr>
           <a:lstStyle xmlns:a="http://schemas.openxmlformats.org/drawingml/2006/main"/>
           <a:p xmlns:a="http://schemas.openxmlformats.org/drawingml/2006/main">
@@ -8691,7 +8824,7 @@
                 <a:ea typeface="-apple-system"/>
                 <a:cs typeface="-apple-system"/>
               </a:rPr>
-              <a:t>Similarity-only</a:t>
+              <a:t>Raw transfer / no Gate</a:t>
             </a:r>
           </a:p>
         </p:txBody>
@@ -8730,7 +8863,7 @@
         </p:spPr>
         <p:txBody>
           <a:bodyPr xmlns:a="http://schemas.openxmlformats.org/drawingml/2006/main" wrap="square" lIns="76200" tIns="66675" rIns="76200" bIns="66675" anchor="ctr">
-            <a:normAutofit/>
+            <a:normAutofit fontScale="100000"/>
           </a:bodyPr>
           <a:lstStyle xmlns:a="http://schemas.openxmlformats.org/drawingml/2006/main"/>
           <a:p xmlns:a="http://schemas.openxmlformats.org/drawingml/2006/main">
@@ -8754,7 +8887,7 @@
                 <a:ea typeface="-apple-system"/>
                 <a:cs typeface="-apple-system"/>
               </a:rPr>
-              <a:t>schema router only</a:t>
+              <a:t>always deploy source route</a:t>
             </a:r>
           </a:p>
         </p:txBody>
@@ -8793,7 +8926,7 @@
         </p:spPr>
         <p:txBody>
           <a:bodyPr xmlns:a="http://schemas.openxmlformats.org/drawingml/2006/main" wrap="square" lIns="76200" tIns="66675" rIns="76200" bIns="66675" anchor="ctr">
-            <a:normAutofit/>
+            <a:normAutofit fontScale="100000"/>
           </a:bodyPr>
           <a:lstStyle xmlns:a="http://schemas.openxmlformats.org/drawingml/2006/main"/>
           <a:p xmlns:a="http://schemas.openxmlformats.org/drawingml/2006/main">
@@ -8817,7 +8950,7 @@
                 <a:ea typeface="-apple-system"/>
                 <a:cs typeface="-apple-system"/>
               </a:rPr>
-              <a:t>检验表面相似度</a:t>
+              <a:t>量化 Gate 的负迁移保护</a:t>
             </a:r>
           </a:p>
         </p:txBody>
@@ -8856,7 +8989,7 @@
         </p:spPr>
         <p:txBody>
           <a:bodyPr xmlns:a="http://schemas.openxmlformats.org/drawingml/2006/main" wrap="square" lIns="76200" tIns="66675" rIns="76200" bIns="66675" anchor="ctr">
-            <a:normAutofit/>
+            <a:normAutofit fontScale="100000"/>
           </a:bodyPr>
           <a:lstStyle xmlns:a="http://schemas.openxmlformats.org/drawingml/2006/main"/>
           <a:p xmlns:a="http://schemas.openxmlformats.org/drawingml/2006/main">
@@ -8880,7 +9013,7 @@
                 <a:ea typeface="-apple-system"/>
                 <a:cs typeface="-apple-system"/>
               </a:rPr>
-              <a:t>PARTIAL</a:t>
+              <a:t>2 NEG · 1 UNC.</a:t>
             </a:r>
           </a:p>
         </p:txBody>
@@ -8919,7 +9052,7 @@
         </p:spPr>
         <p:txBody>
           <a:bodyPr xmlns:a="http://schemas.openxmlformats.org/drawingml/2006/main" wrap="square" lIns="76200" tIns="66675" rIns="76200" bIns="66675" anchor="ctr">
-            <a:normAutofit/>
+            <a:normAutofit fontScale="100000"/>
           </a:bodyPr>
           <a:lstStyle xmlns:a="http://schemas.openxmlformats.org/drawingml/2006/main"/>
           <a:p xmlns:a="http://schemas.openxmlformats.org/drawingml/2006/main">
@@ -8943,7 +9076,7 @@
                 <a:ea typeface="-apple-system"/>
                 <a:cs typeface="-apple-system"/>
               </a:rPr>
-              <a:t>Without gate</a:t>
+              <a:t>Random-transfer</a:t>
             </a:r>
           </a:p>
         </p:txBody>
@@ -8982,7 +9115,7 @@
         </p:spPr>
         <p:txBody>
           <a:bodyPr xmlns:a="http://schemas.openxmlformats.org/drawingml/2006/main" wrap="square" lIns="76200" tIns="66675" rIns="76200" bIns="66675" anchor="ctr">
-            <a:normAutofit/>
+            <a:normAutofit fontScale="100000"/>
           </a:bodyPr>
           <a:lstStyle xmlns:a="http://schemas.openxmlformats.org/drawingml/2006/main"/>
           <a:p xmlns:a="http://schemas.openxmlformats.org/drawingml/2006/main">
@@ -9006,7 +9139,7 @@
                 <a:ea typeface="-apple-system"/>
                 <a:cs typeface="-apple-system"/>
               </a:rPr>
-              <a:t>always deploy transfer</a:t>
+              <a:t>matched random rule</a:t>
             </a:r>
           </a:p>
         </p:txBody>
@@ -9045,7 +9178,7 @@
         </p:spPr>
         <p:txBody>
           <a:bodyPr xmlns:a="http://schemas.openxmlformats.org/drawingml/2006/main" wrap="square" lIns="76200" tIns="66675" rIns="76200" bIns="66675" anchor="ctr">
-            <a:normAutofit/>
+            <a:normAutofit fontScale="100000"/>
           </a:bodyPr>
           <a:lstStyle xmlns:a="http://schemas.openxmlformats.org/drawingml/2006/main"/>
           <a:p xmlns:a="http://schemas.openxmlformats.org/drawingml/2006/main">
@@ -9069,7 +9202,7 @@
                 <a:ea typeface="-apple-system"/>
                 <a:cs typeface="-apple-system"/>
               </a:rPr>
-              <a:t>量化负迁移保护</a:t>
+              <a:t>排除规则形式本身的红利</a:t>
             </a:r>
           </a:p>
         </p:txBody>
@@ -9108,7 +9241,7 @@
         </p:spPr>
         <p:txBody>
           <a:bodyPr xmlns:a="http://schemas.openxmlformats.org/drawingml/2006/main" wrap="square" lIns="76200" tIns="66675" rIns="76200" bIns="66675" anchor="ctr">
-            <a:normAutofit/>
+            <a:normAutofit fontScale="100000"/>
           </a:bodyPr>
           <a:lstStyle xmlns:a="http://schemas.openxmlformats.org/drawingml/2006/main"/>
           <a:p xmlns:a="http://schemas.openxmlformats.org/drawingml/2006/main">
@@ -9132,7 +9265,7 @@
                 <a:ea typeface="-apple-system"/>
                 <a:cs typeface="-apple-system"/>
               </a:rPr>
-              <a:t>IMPLEMENTED</a:t>
+              <a:t>PARTIAL</a:t>
             </a:r>
           </a:p>
         </p:txBody>
@@ -9171,7 +9304,7 @@
         </p:spPr>
         <p:txBody>
           <a:bodyPr xmlns:a="http://schemas.openxmlformats.org/drawingml/2006/main" wrap="square" lIns="76200" tIns="66675" rIns="76200" bIns="66675" anchor="ctr">
-            <a:normAutofit/>
+            <a:normAutofit fontScale="100000"/>
           </a:bodyPr>
           <a:lstStyle xmlns:a="http://schemas.openxmlformats.org/drawingml/2006/main"/>
           <a:p xmlns:a="http://schemas.openxmlformats.org/drawingml/2006/main">
@@ -9195,7 +9328,7 @@
                 <a:ea typeface="-apple-system"/>
                 <a:cs typeface="-apple-system"/>
               </a:rPr>
-              <a:t>Without hypothesis validation</a:t>
+              <a:t>Similarity / no validation</a:t>
             </a:r>
           </a:p>
         </p:txBody>
@@ -9234,7 +9367,7 @@
         </p:spPr>
         <p:txBody>
           <a:bodyPr xmlns:a="http://schemas.openxmlformats.org/drawingml/2006/main" wrap="square" lIns="76200" tIns="66675" rIns="76200" bIns="66675" anchor="ctr">
-            <a:normAutofit/>
+            <a:normAutofit fontScale="100000"/>
           </a:bodyPr>
           <a:lstStyle xmlns:a="http://schemas.openxmlformats.org/drawingml/2006/main"/>
           <a:p xmlns:a="http://schemas.openxmlformats.org/drawingml/2006/main">
@@ -9258,7 +9391,7 @@
                 <a:ea typeface="-apple-system"/>
                 <a:cs typeface="-apple-system"/>
               </a:rPr>
-              <a:t>direct prior / no validation</a:t>
+              <a:t>schema-only or direct prior</a:t>
             </a:r>
           </a:p>
         </p:txBody>
@@ -9297,7 +9430,7 @@
         </p:spPr>
         <p:txBody>
           <a:bodyPr xmlns:a="http://schemas.openxmlformats.org/drawingml/2006/main" wrap="square" lIns="76200" tIns="66675" rIns="76200" bIns="66675" anchor="ctr">
-            <a:normAutofit/>
+            <a:normAutofit fontScale="100000"/>
           </a:bodyPr>
           <a:lstStyle xmlns:a="http://schemas.openxmlformats.org/drawingml/2006/main"/>
           <a:p xmlns:a="http://schemas.openxmlformats.org/drawingml/2006/main">
@@ -9321,7 +9454,7 @@
                 <a:ea typeface="-apple-system"/>
                 <a:cs typeface="-apple-system"/>
               </a:rPr>
-              <a:t>检验 hypothesis 质量</a:t>
+              <a:t>检验 hypothesis 与 evidence</a:t>
             </a:r>
           </a:p>
         </p:txBody>
@@ -9360,7 +9493,7 @@
         </p:spPr>
         <p:txBody>
           <a:bodyPr xmlns:a="http://schemas.openxmlformats.org/drawingml/2006/main" wrap="square" lIns="76200" tIns="66675" rIns="76200" bIns="66675" anchor="ctr">
-            <a:normAutofit/>
+            <a:normAutofit fontScale="100000"/>
           </a:bodyPr>
           <a:lstStyle xmlns:a="http://schemas.openxmlformats.org/drawingml/2006/main"/>
           <a:p xmlns:a="http://schemas.openxmlformats.org/drawingml/2006/main">
@@ -9423,7 +9556,7 @@
         </p:spPr>
         <p:txBody>
           <a:bodyPr xmlns:a="http://schemas.openxmlformats.org/drawingml/2006/main" wrap="square" lIns="76200" tIns="66675" rIns="76200" bIns="66675" anchor="ctr">
-            <a:normAutofit/>
+            <a:normAutofit fontScale="100000"/>
           </a:bodyPr>
           <a:lstStyle xmlns:a="http://schemas.openxmlformats.org/drawingml/2006/main"/>
           <a:p xmlns:a="http://schemas.openxmlformats.org/drawingml/2006/main">
@@ -9447,7 +9580,7 @@
                 <a:ea typeface="-apple-system"/>
                 <a:cs typeface="-apple-system"/>
               </a:rPr>
-              <a:t>Full framework</a:t>
+              <a:t>Full CARE 2.0</a:t>
             </a:r>
           </a:p>
         </p:txBody>
@@ -9486,7 +9619,7 @@
         </p:spPr>
         <p:txBody>
           <a:bodyPr xmlns:a="http://schemas.openxmlformats.org/drawingml/2006/main" wrap="square" lIns="76200" tIns="66675" rIns="76200" bIns="66675" anchor="ctr">
-            <a:normAutofit/>
+            <a:normAutofit fontScale="100000"/>
           </a:bodyPr>
           <a:lstStyle xmlns:a="http://schemas.openxmlformats.org/drawingml/2006/main"/>
           <a:p xmlns:a="http://schemas.openxmlformats.org/drawingml/2006/main">
@@ -9549,7 +9682,7 @@
         </p:spPr>
         <p:txBody>
           <a:bodyPr xmlns:a="http://schemas.openxmlformats.org/drawingml/2006/main" wrap="square" lIns="76200" tIns="66675" rIns="76200" bIns="66675" anchor="ctr">
-            <a:normAutofit/>
+            <a:normAutofit fontScale="100000"/>
           </a:bodyPr>
           <a:lstStyle xmlns:a="http://schemas.openxmlformats.org/drawingml/2006/main"/>
           <a:p xmlns:a="http://schemas.openxmlformats.org/drawingml/2006/main">
@@ -9573,7 +9706,7 @@
                 <a:ea typeface="-apple-system"/>
                 <a:cs typeface="-apple-system"/>
               </a:rPr>
-              <a:t>完整方法</a:t>
+              <a:t>可审计部署与 exact fallback</a:t>
             </a:r>
           </a:p>
         </p:txBody>
@@ -9612,7 +9745,7 @@
         </p:spPr>
         <p:txBody>
           <a:bodyPr xmlns:a="http://schemas.openxmlformats.org/drawingml/2006/main" wrap="square" lIns="76200" tIns="66675" rIns="76200" bIns="66675" anchor="ctr">
-            <a:normAutofit/>
+            <a:normAutofit fontScale="100000"/>
           </a:bodyPr>
           <a:lstStyle xmlns:a="http://schemas.openxmlformats.org/drawingml/2006/main"/>
           <a:p xmlns:a="http://schemas.openxmlformats.org/drawingml/2006/main">
@@ -9636,7 +9769,7 @@
                 <a:ea typeface="-apple-system"/>
                 <a:cs typeface="-apple-system"/>
               </a:rPr>
-              <a:t>7 ROUTES</a:t>
+              <a:t>4 T · 3 FALLBACK</a:t>
             </a:r>
           </a:p>
         </p:txBody>
@@ -9677,7 +9810,7 @@
         </p:spPr>
         <p:txBody>
           <a:bodyPr xmlns:a="http://schemas.openxmlformats.org/drawingml/2006/main" wrap="square" lIns="95250" tIns="76200" rIns="95250" bIns="76200" anchor="ctr">
-            <a:normAutofit/>
+            <a:normAutofit fontScale="100000"/>
           </a:bodyPr>
           <a:lstStyle xmlns:a="http://schemas.openxmlformats.org/drawingml/2006/main"/>
           <a:p xmlns:a="http://schemas.openxmlformats.org/drawingml/2006/main">
@@ -9701,7 +9834,7 @@
                 <a:ea typeface="-apple-system"/>
                 <a:cs typeface="-apple-system"/>
               </a:rPr>
-              <a:t>统一报告：paired mean gain · 95% CI / q-value · practical effect · negative-transfer rate · acceptance rate · rounds saved</a:t>
+              <a:t>例：ChemLex→BH +9.20 vs LLM / +8.10 vs BO · FreeSolv→Lipo +2.98 / +4.99 · 100 held-out seeds</a:t>
             </a:r>
           </a:p>
         </p:txBody>
@@ -9737,7 +9870,7 @@
           <p:nvPr/>
         </p:nvPicPr>
         <p:blipFill>
-          <a:blip xmlns:r="http://schemas.openxmlformats.org/officeDocument/2006/relationships" xmlns:a="http://schemas.openxmlformats.org/drawingml/2006/main" r:embed="Rd57fd45b6c024ad6"/>
+          <a:blip xmlns:r="http://schemas.openxmlformats.org/officeDocument/2006/relationships" xmlns:a="http://schemas.openxmlformats.org/drawingml/2006/main" r:embed="Rc78c277913674349"/>
           <a:stretch xmlns:a="http://schemas.openxmlformats.org/drawingml/2006/main">
             <a:fillRect l="0" t="0" r="0" b="0"/>
           </a:stretch>
@@ -9905,7 +10038,7 @@
           <p:nvPr/>
         </p:nvPicPr>
         <p:blipFill>
-          <a:blip xmlns:r="http://schemas.openxmlformats.org/officeDocument/2006/relationships" xmlns:a="http://schemas.openxmlformats.org/drawingml/2006/main" r:embed="R79adde594ba644d9"/>
+          <a:blip xmlns:r="http://schemas.openxmlformats.org/officeDocument/2006/relationships" xmlns:a="http://schemas.openxmlformats.org/drawingml/2006/main" r:embed="R4c8d2cf538f946c1"/>
           <a:stretch xmlns:a="http://schemas.openxmlformats.org/drawingml/2006/main">
             <a:fillRect l="0" t="0" r="0" b="0"/>
           </a:stretch>
@@ -9969,7 +10102,7 @@
           <p:nvPr/>
         </p:nvPicPr>
         <p:blipFill>
-          <a:blip xmlns:r="http://schemas.openxmlformats.org/officeDocument/2006/relationships" xmlns:a="http://schemas.openxmlformats.org/drawingml/2006/main" r:embed="R516cd545323b4d05"/>
+          <a:blip xmlns:r="http://schemas.openxmlformats.org/officeDocument/2006/relationships" xmlns:a="http://schemas.openxmlformats.org/drawingml/2006/main" r:embed="Rd7f72f65e8364068"/>
           <a:stretch xmlns:a="http://schemas.openxmlformats.org/drawingml/2006/main">
             <a:fillRect l="0" t="0" r="0" b="0"/>
           </a:stretch>
@@ -10812,7 +10945,7 @@
           <p:nvPr/>
         </p:nvPicPr>
         <p:blipFill>
-          <a:blip xmlns:r="http://schemas.openxmlformats.org/officeDocument/2006/relationships" xmlns:a="http://schemas.openxmlformats.org/drawingml/2006/main" r:embed="Rbc8b9826d83d4bfe"/>
+          <a:blip xmlns:r="http://schemas.openxmlformats.org/officeDocument/2006/relationships" xmlns:a="http://schemas.openxmlformats.org/drawingml/2006/main" r:embed="Rf42f8852eb5844f7"/>
           <a:stretch xmlns:a="http://schemas.openxmlformats.org/drawingml/2006/main"/>
         </p:blipFill>
         <p:spPr>
@@ -10855,7 +10988,7 @@
         </p:spPr>
         <p:txBody>
           <a:bodyPr xmlns:a="http://schemas.openxmlformats.org/drawingml/2006/main" wrap="square" lIns="0" tIns="0" rIns="0" bIns="0" anchor="t">
-            <a:normAutofit/>
+            <a:normAutofit fontScale="100000"/>
           </a:bodyPr>
           <a:lstStyle xmlns:a="http://schemas.openxmlformats.org/drawingml/2006/main"/>
           <a:p xmlns:a="http://schemas.openxmlformats.org/drawingml/2006/main">
@@ -10879,8 +11012,21 @@
                 <a:ea typeface="-apple-system"/>
                 <a:cs typeface="-apple-system"/>
               </a:rPr>
-              <a:t>已部署路线的</a:t>
-            </a:r>
+              <a:t>节省轮数：matched-final</a:t>
+            </a:r>
+          </a:p>
+          <a:p xmlns:a="http://schemas.openxmlformats.org/drawingml/2006/main">
+            <a:pPr algn="l">
+              <a:buNone/>
+              <a:defRPr sz="1125" b="1">
+                <a:solidFill>
+                  <a:srgbClr val="2B6CB0"/>
+                </a:solidFill>
+                <a:latin typeface="-apple-system"/>
+                <a:ea typeface="-apple-system"/>
+                <a:cs typeface="-apple-system"/>
+              </a:defRPr>
+            </a:pPr>
             <a:r>
               <a:rPr sz="1125" b="1">
                 <a:solidFill>
@@ -10890,7 +11036,7 @@
                 <a:ea typeface="-apple-system"/>
                 <a:cs typeface="-apple-system"/>
               </a:rPr>
-              <a:t> paired round saving</a:t>
+              <a:t>paired 95% CI</a:t>
             </a:r>
           </a:p>
         </p:txBody>
@@ -10970,8 +11116,91 @@
         </p:nvSpPr>
         <p:spPr>
           <a:xfrm xmlns:a="http://schemas.openxmlformats.org/drawingml/2006/main">
-            <a:off x="7810500" y="1733550"/>
-            <a:ext cx="762000" cy="266700"/>
+            <a:off x="7810500" y="1685925"/>
+            <a:ext cx="762000" cy="361950"/>
+          </a:xfrm>
+          <a:prstGeom xmlns:a="http://schemas.openxmlformats.org/drawingml/2006/main" prst="rect">
+            <a:avLst/>
+          </a:prstGeom>
+          <a:noFill xmlns:a="http://schemas.openxmlformats.org/drawingml/2006/main"/>
+          <a:ln xmlns:a="http://schemas.openxmlformats.org/drawingml/2006/main" w="0">
+            <a:noFill/>
+            <a:prstDash val="solid"/>
+          </a:ln>
+        </p:spPr>
+        <p:txBody>
+          <a:bodyPr xmlns:a="http://schemas.openxmlformats.org/drawingml/2006/main" wrap="square" lIns="0" tIns="0" rIns="0" bIns="0" anchor="t">
+            <a:normAutofit fontScale="100000"/>
+          </a:bodyPr>
+          <a:lstStyle xmlns:a="http://schemas.openxmlformats.org/drawingml/2006/main"/>
+          <a:p xmlns:a="http://schemas.openxmlformats.org/drawingml/2006/main">
+            <a:pPr algn="r">
+              <a:buNone/>
+              <a:defRPr sz="900" b="1">
+                <a:solidFill>
+                  <a:srgbClr val="198754"/>
+                </a:solidFill>
+                <a:latin typeface="-apple-system"/>
+                <a:ea typeface="-apple-system"/>
+                <a:cs typeface="-apple-system"/>
+              </a:defRPr>
+            </a:pPr>
+            <a:r>
+              <a:rPr sz="900" b="1">
+                <a:solidFill>
+                  <a:srgbClr val="198754"/>
+                </a:solidFill>
+                <a:latin typeface="-apple-system"/>
+                <a:ea typeface="-apple-system"/>
+                <a:cs typeface="-apple-system"/>
+              </a:rPr>
+              <a:t>2.99</a:t>
+            </a:r>
+          </a:p>
+          <a:p xmlns:a="http://schemas.openxmlformats.org/drawingml/2006/main">
+            <a:pPr algn="r">
+              <a:buNone/>
+              <a:defRPr sz="900" b="1">
+                <a:solidFill>
+                  <a:srgbClr val="198754"/>
+                </a:solidFill>
+                <a:latin typeface="-apple-system"/>
+                <a:ea typeface="-apple-system"/>
+                <a:cs typeface="-apple-system"/>
+              </a:defRPr>
+            </a:pPr>
+            <a:r>
+              <a:rPr sz="900" b="1">
+                <a:solidFill>
+                  <a:srgbClr val="198754"/>
+                </a:solidFill>
+                <a:latin typeface="-apple-system"/>
+                <a:ea typeface="-apple-system"/>
+                <a:cs typeface="-apple-system"/>
+              </a:rPr>
+              <a:t>[2.05, 3.93]</a:t>
+            </a:r>
+          </a:p>
+        </p:txBody>
+      </p:sp>
+      <p:sp>
+        <p:nvSpPr>
+          <p:cNvPr id="37" name="round-label-1">
+            <a:extLst xmlns:a="http://schemas.openxmlformats.org/drawingml/2006/main">
+              <a:ext uri="{FF2B5EF4-FFF2-40B4-BE49-F238E27FC236}">
+                <a16:creationId xmlns:a16="http://schemas.microsoft.com/office/drawing/2014/main" id="{4E42CB59-FE44-472F-BB3D-F249FA3A8FD1}"/>
+              </a:ext>
+            </a:extLst>
+          </p:cNvPr>
+          <p:cNvSpPr>
+            <a:spLocks xmlns:a="http://schemas.openxmlformats.org/drawingml/2006/main" noGrp="1"/>
+          </p:cNvSpPr>
+          <p:nvPr/>
+        </p:nvSpPr>
+        <p:spPr>
+          <a:xfrm xmlns:a="http://schemas.openxmlformats.org/drawingml/2006/main">
+            <a:off x="6572250" y="2162175"/>
+            <a:ext cx="1190625" cy="266700"/>
           </a:xfrm>
           <a:prstGeom xmlns:a="http://schemas.openxmlformats.org/drawingml/2006/main" prst="rect">
             <a:avLst/>
@@ -10988,6 +11217,65 @@
           </a:bodyPr>
           <a:lstStyle xmlns:a="http://schemas.openxmlformats.org/drawingml/2006/main"/>
           <a:p xmlns:a="http://schemas.openxmlformats.org/drawingml/2006/main">
+            <a:pPr algn="l">
+              <a:buNone/>
+              <a:defRPr sz="863" b="1">
+                <a:solidFill>
+                  <a:srgbClr val="17212B"/>
+                </a:solidFill>
+                <a:latin typeface="-apple-system"/>
+                <a:ea typeface="-apple-system"/>
+                <a:cs typeface="-apple-system"/>
+              </a:defRPr>
+            </a:pPr>
+            <a:r>
+              <a:rPr sz="863" b="1">
+                <a:solidFill>
+                  <a:srgbClr val="17212B"/>
+                </a:solidFill>
+                <a:latin typeface="-apple-system"/>
+                <a:ea typeface="-apple-system"/>
+                <a:cs typeface="-apple-system"/>
+              </a:rPr>
+              <a:t>Dielectric → Gap</a:t>
+            </a:r>
+          </a:p>
+        </p:txBody>
+      </p:sp>
+      <p:sp>
+        <p:nvSpPr>
+          <p:cNvPr id="38" name="round-value-1">
+            <a:extLst xmlns:a="http://schemas.openxmlformats.org/drawingml/2006/main">
+              <a:ext uri="{FF2B5EF4-FFF2-40B4-BE49-F238E27FC236}">
+                <a16:creationId xmlns:a16="http://schemas.microsoft.com/office/drawing/2014/main" id="{8629AE7D-F5C3-4595-AF3D-DA3A8A3F58F7}"/>
+              </a:ext>
+            </a:extLst>
+          </p:cNvPr>
+          <p:cNvSpPr>
+            <a:spLocks xmlns:a="http://schemas.openxmlformats.org/drawingml/2006/main" noGrp="1"/>
+          </p:cNvSpPr>
+          <p:nvPr/>
+        </p:nvSpPr>
+        <p:spPr>
+          <a:xfrm xmlns:a="http://schemas.openxmlformats.org/drawingml/2006/main">
+            <a:off x="7810500" y="2114550"/>
+            <a:ext cx="762000" cy="361950"/>
+          </a:xfrm>
+          <a:prstGeom xmlns:a="http://schemas.openxmlformats.org/drawingml/2006/main" prst="rect">
+            <a:avLst/>
+          </a:prstGeom>
+          <a:noFill xmlns:a="http://schemas.openxmlformats.org/drawingml/2006/main"/>
+          <a:ln xmlns:a="http://schemas.openxmlformats.org/drawingml/2006/main" w="0">
+            <a:noFill/>
+            <a:prstDash val="solid"/>
+          </a:ln>
+        </p:spPr>
+        <p:txBody>
+          <a:bodyPr xmlns:a="http://schemas.openxmlformats.org/drawingml/2006/main" wrap="square" lIns="0" tIns="0" rIns="0" bIns="0" anchor="t">
+            <a:normAutofit fontScale="100000"/>
+          </a:bodyPr>
+          <a:lstStyle xmlns:a="http://schemas.openxmlformats.org/drawingml/2006/main"/>
+          <a:p xmlns:a="http://schemas.openxmlformats.org/drawingml/2006/main">
             <a:pPr algn="r">
               <a:buNone/>
               <a:defRPr sz="900" b="1">
@@ -11008,28 +11296,52 @@
                 <a:ea typeface="-apple-system"/>
                 <a:cs typeface="-apple-system"/>
               </a:rPr>
-              <a:t>2.99 / 3.62</a:t>
-            </a:r>
-          </a:p>
-        </p:txBody>
-      </p:sp>
-      <p:sp>
-        <p:nvSpPr>
-          <p:cNvPr id="37" name="round-label-1">
-            <a:extLst xmlns:a="http://schemas.openxmlformats.org/drawingml/2006/main">
-              <a:ext uri="{FF2B5EF4-FFF2-40B4-BE49-F238E27FC236}">
-                <a16:creationId xmlns:a16="http://schemas.microsoft.com/office/drawing/2014/main" id="{4E42CB59-FE44-472F-BB3D-F249FA3A8FD1}"/>
-              </a:ext>
-            </a:extLst>
-          </p:cNvPr>
-          <p:cNvSpPr>
-            <a:spLocks xmlns:a="http://schemas.openxmlformats.org/drawingml/2006/main" noGrp="1"/>
-          </p:cNvSpPr>
-          <p:nvPr/>
-        </p:nvSpPr>
-        <p:spPr>
-          <a:xfrm xmlns:a="http://schemas.openxmlformats.org/drawingml/2006/main">
-            <a:off x="6572250" y="2162175"/>
+              <a:t>6.00</a:t>
+            </a:r>
+          </a:p>
+          <a:p xmlns:a="http://schemas.openxmlformats.org/drawingml/2006/main">
+            <a:pPr algn="r">
+              <a:buNone/>
+              <a:defRPr sz="900" b="1">
+                <a:solidFill>
+                  <a:srgbClr val="198754"/>
+                </a:solidFill>
+                <a:latin typeface="-apple-system"/>
+                <a:ea typeface="-apple-system"/>
+                <a:cs typeface="-apple-system"/>
+              </a:defRPr>
+            </a:pPr>
+            <a:r>
+              <a:rPr sz="900" b="1">
+                <a:solidFill>
+                  <a:srgbClr val="198754"/>
+                </a:solidFill>
+                <a:latin typeface="-apple-system"/>
+                <a:ea typeface="-apple-system"/>
+                <a:cs typeface="-apple-system"/>
+              </a:rPr>
+              <a:t>[5.14, 6.86]</a:t>
+            </a:r>
+          </a:p>
+        </p:txBody>
+      </p:sp>
+      <p:sp>
+        <p:nvSpPr>
+          <p:cNvPr id="39" name="round-label-2">
+            <a:extLst xmlns:a="http://schemas.openxmlformats.org/drawingml/2006/main">
+              <a:ext uri="{FF2B5EF4-FFF2-40B4-BE49-F238E27FC236}">
+                <a16:creationId xmlns:a16="http://schemas.microsoft.com/office/drawing/2014/main" id="{08F6BA6B-65FA-4902-9D50-C43DF23FBCC4}"/>
+              </a:ext>
+            </a:extLst>
+          </p:cNvPr>
+          <p:cNvSpPr>
+            <a:spLocks xmlns:a="http://schemas.openxmlformats.org/drawingml/2006/main" noGrp="1"/>
+          </p:cNvSpPr>
+          <p:nvPr/>
+        </p:nvSpPr>
+        <p:spPr>
+          <a:xfrm xmlns:a="http://schemas.openxmlformats.org/drawingml/2006/main">
+            <a:off x="6572250" y="2590800"/>
             <a:ext cx="1190625" cy="266700"/>
           </a:xfrm>
           <a:prstGeom xmlns:a="http://schemas.openxmlformats.org/drawingml/2006/main" prst="rect">
@@ -11067,29 +11379,112 @@
                 <a:ea typeface="-apple-system"/>
                 <a:cs typeface="-apple-system"/>
               </a:rPr>
-              <a:t>Dielectric → Gap</a:t>
-            </a:r>
-          </a:p>
-        </p:txBody>
-      </p:sp>
-      <p:sp>
-        <p:nvSpPr>
-          <p:cNvPr id="38" name="round-value-1">
-            <a:extLst xmlns:a="http://schemas.openxmlformats.org/drawingml/2006/main">
-              <a:ext uri="{FF2B5EF4-FFF2-40B4-BE49-F238E27FC236}">
-                <a16:creationId xmlns:a16="http://schemas.microsoft.com/office/drawing/2014/main" id="{8629AE7D-F5C3-4595-AF3D-DA3A8A3F58F7}"/>
-              </a:ext>
-            </a:extLst>
-          </p:cNvPr>
-          <p:cNvSpPr>
-            <a:spLocks xmlns:a="http://schemas.openxmlformats.org/drawingml/2006/main" noGrp="1"/>
-          </p:cNvSpPr>
-          <p:nvPr/>
-        </p:nvSpPr>
-        <p:spPr>
-          <a:xfrm xmlns:a="http://schemas.openxmlformats.org/drawingml/2006/main">
-            <a:off x="7810500" y="2162175"/>
-            <a:ext cx="762000" cy="266700"/>
+              <a:t>Gap → Dielectric</a:t>
+            </a:r>
+          </a:p>
+        </p:txBody>
+      </p:sp>
+      <p:sp>
+        <p:nvSpPr>
+          <p:cNvPr id="40" name="round-value-2">
+            <a:extLst xmlns:a="http://schemas.openxmlformats.org/drawingml/2006/main">
+              <a:ext uri="{FF2B5EF4-FFF2-40B4-BE49-F238E27FC236}">
+                <a16:creationId xmlns:a16="http://schemas.microsoft.com/office/drawing/2014/main" id="{69CFAF51-C1C7-40D4-872C-531E7D11C6E4}"/>
+              </a:ext>
+            </a:extLst>
+          </p:cNvPr>
+          <p:cNvSpPr>
+            <a:spLocks xmlns:a="http://schemas.openxmlformats.org/drawingml/2006/main" noGrp="1"/>
+          </p:cNvSpPr>
+          <p:nvPr/>
+        </p:nvSpPr>
+        <p:spPr>
+          <a:xfrm xmlns:a="http://schemas.openxmlformats.org/drawingml/2006/main">
+            <a:off x="7810500" y="2543175"/>
+            <a:ext cx="762000" cy="361950"/>
+          </a:xfrm>
+          <a:prstGeom xmlns:a="http://schemas.openxmlformats.org/drawingml/2006/main" prst="rect">
+            <a:avLst/>
+          </a:prstGeom>
+          <a:noFill xmlns:a="http://schemas.openxmlformats.org/drawingml/2006/main"/>
+          <a:ln xmlns:a="http://schemas.openxmlformats.org/drawingml/2006/main" w="0">
+            <a:noFill/>
+            <a:prstDash val="solid"/>
+          </a:ln>
+        </p:spPr>
+        <p:txBody>
+          <a:bodyPr xmlns:a="http://schemas.openxmlformats.org/drawingml/2006/main" wrap="square" lIns="0" tIns="0" rIns="0" bIns="0" anchor="t">
+            <a:normAutofit fontScale="100000"/>
+          </a:bodyPr>
+          <a:lstStyle xmlns:a="http://schemas.openxmlformats.org/drawingml/2006/main"/>
+          <a:p xmlns:a="http://schemas.openxmlformats.org/drawingml/2006/main">
+            <a:pPr algn="r">
+              <a:buNone/>
+              <a:defRPr sz="900" b="1">
+                <a:solidFill>
+                  <a:srgbClr val="198754"/>
+                </a:solidFill>
+                <a:latin typeface="-apple-system"/>
+                <a:ea typeface="-apple-system"/>
+                <a:cs typeface="-apple-system"/>
+              </a:defRPr>
+            </a:pPr>
+            <a:r>
+              <a:rPr sz="900" b="1">
+                <a:solidFill>
+                  <a:srgbClr val="198754"/>
+                </a:solidFill>
+                <a:latin typeface="-apple-system"/>
+                <a:ea typeface="-apple-system"/>
+                <a:cs typeface="-apple-system"/>
+              </a:rPr>
+              <a:t>5.03</a:t>
+            </a:r>
+          </a:p>
+          <a:p xmlns:a="http://schemas.openxmlformats.org/drawingml/2006/main">
+            <a:pPr algn="r">
+              <a:buNone/>
+              <a:defRPr sz="900" b="1">
+                <a:solidFill>
+                  <a:srgbClr val="198754"/>
+                </a:solidFill>
+                <a:latin typeface="-apple-system"/>
+                <a:ea typeface="-apple-system"/>
+                <a:cs typeface="-apple-system"/>
+              </a:defRPr>
+            </a:pPr>
+            <a:r>
+              <a:rPr sz="900" b="1">
+                <a:solidFill>
+                  <a:srgbClr val="198754"/>
+                </a:solidFill>
+                <a:latin typeface="-apple-system"/>
+                <a:ea typeface="-apple-system"/>
+                <a:cs typeface="-apple-system"/>
+              </a:rPr>
+              <a:t>[4.27, 5.79]</a:t>
+            </a:r>
+          </a:p>
+        </p:txBody>
+      </p:sp>
+      <p:sp>
+        <p:nvSpPr>
+          <p:cNvPr id="41" name="round-label-3">
+            <a:extLst xmlns:a="http://schemas.openxmlformats.org/drawingml/2006/main">
+              <a:ext uri="{FF2B5EF4-FFF2-40B4-BE49-F238E27FC236}">
+                <a16:creationId xmlns:a16="http://schemas.microsoft.com/office/drawing/2014/main" id="{AB86BC24-A58E-4B67-A3BC-FB59CD9C52C0}"/>
+              </a:ext>
+            </a:extLst>
+          </p:cNvPr>
+          <p:cNvSpPr>
+            <a:spLocks xmlns:a="http://schemas.openxmlformats.org/drawingml/2006/main" noGrp="1"/>
+          </p:cNvSpPr>
+          <p:nvPr/>
+        </p:nvSpPr>
+        <p:spPr>
+          <a:xfrm xmlns:a="http://schemas.openxmlformats.org/drawingml/2006/main">
+            <a:off x="6572250" y="3019425"/>
+            <a:ext cx="1190625" cy="266700"/>
           </a:xfrm>
           <a:prstGeom xmlns:a="http://schemas.openxmlformats.org/drawingml/2006/main" prst="rect">
             <a:avLst/>
@@ -11106,6 +11501,65 @@
           </a:bodyPr>
           <a:lstStyle xmlns:a="http://schemas.openxmlformats.org/drawingml/2006/main"/>
           <a:p xmlns:a="http://schemas.openxmlformats.org/drawingml/2006/main">
+            <a:pPr algn="l">
+              <a:buNone/>
+              <a:defRPr sz="863" b="1">
+                <a:solidFill>
+                  <a:srgbClr val="17212B"/>
+                </a:solidFill>
+                <a:latin typeface="-apple-system"/>
+                <a:ea typeface="-apple-system"/>
+                <a:cs typeface="-apple-system"/>
+              </a:defRPr>
+            </a:pPr>
+            <a:r>
+              <a:rPr sz="863" b="1">
+                <a:solidFill>
+                  <a:srgbClr val="17212B"/>
+                </a:solidFill>
+                <a:latin typeface="-apple-system"/>
+                <a:ea typeface="-apple-system"/>
+                <a:cs typeface="-apple-system"/>
+              </a:rPr>
+              <a:t>FreeSolv → Lipo</a:t>
+            </a:r>
+          </a:p>
+        </p:txBody>
+      </p:sp>
+      <p:sp>
+        <p:nvSpPr>
+          <p:cNvPr id="42" name="round-value-3">
+            <a:extLst xmlns:a="http://schemas.openxmlformats.org/drawingml/2006/main">
+              <a:ext uri="{FF2B5EF4-FFF2-40B4-BE49-F238E27FC236}">
+                <a16:creationId xmlns:a16="http://schemas.microsoft.com/office/drawing/2014/main" id="{BBAFFDA6-7421-4275-A8B9-412451E96210}"/>
+              </a:ext>
+            </a:extLst>
+          </p:cNvPr>
+          <p:cNvSpPr>
+            <a:spLocks xmlns:a="http://schemas.openxmlformats.org/drawingml/2006/main" noGrp="1"/>
+          </p:cNvSpPr>
+          <p:nvPr/>
+        </p:nvSpPr>
+        <p:spPr>
+          <a:xfrm xmlns:a="http://schemas.openxmlformats.org/drawingml/2006/main">
+            <a:off x="7810500" y="2971800"/>
+            <a:ext cx="762000" cy="361950"/>
+          </a:xfrm>
+          <a:prstGeom xmlns:a="http://schemas.openxmlformats.org/drawingml/2006/main" prst="rect">
+            <a:avLst/>
+          </a:prstGeom>
+          <a:noFill xmlns:a="http://schemas.openxmlformats.org/drawingml/2006/main"/>
+          <a:ln xmlns:a="http://schemas.openxmlformats.org/drawingml/2006/main" w="0">
+            <a:noFill/>
+            <a:prstDash val="solid"/>
+          </a:ln>
+        </p:spPr>
+        <p:txBody>
+          <a:bodyPr xmlns:a="http://schemas.openxmlformats.org/drawingml/2006/main" wrap="square" lIns="0" tIns="0" rIns="0" bIns="0" anchor="t">
+            <a:normAutofit fontScale="100000"/>
+          </a:bodyPr>
+          <a:lstStyle xmlns:a="http://schemas.openxmlformats.org/drawingml/2006/main"/>
+          <a:p xmlns:a="http://schemas.openxmlformats.org/drawingml/2006/main">
             <a:pPr algn="r">
               <a:buNone/>
               <a:defRPr sz="900" b="1">
@@ -11126,29 +11580,53 @@
                 <a:ea typeface="-apple-system"/>
                 <a:cs typeface="-apple-system"/>
               </a:rPr>
-              <a:t>6.00 / 9.57</a:t>
-            </a:r>
-          </a:p>
-        </p:txBody>
-      </p:sp>
-      <p:sp>
-        <p:nvSpPr>
-          <p:cNvPr id="39" name="round-label-2">
-            <a:extLst xmlns:a="http://schemas.openxmlformats.org/drawingml/2006/main">
-              <a:ext uri="{FF2B5EF4-FFF2-40B4-BE49-F238E27FC236}">
-                <a16:creationId xmlns:a16="http://schemas.microsoft.com/office/drawing/2014/main" id="{08F6BA6B-65FA-4902-9D50-C43DF23FBCC4}"/>
-              </a:ext>
-            </a:extLst>
-          </p:cNvPr>
-          <p:cNvSpPr>
-            <a:spLocks xmlns:a="http://schemas.openxmlformats.org/drawingml/2006/main" noGrp="1"/>
-          </p:cNvSpPr>
-          <p:nvPr/>
-        </p:nvSpPr>
-        <p:spPr>
-          <a:xfrm xmlns:a="http://schemas.openxmlformats.org/drawingml/2006/main">
-            <a:off x="6572250" y="2590800"/>
-            <a:ext cx="1190625" cy="266700"/>
+              <a:t>2.23</a:t>
+            </a:r>
+          </a:p>
+          <a:p xmlns:a="http://schemas.openxmlformats.org/drawingml/2006/main">
+            <a:pPr algn="r">
+              <a:buNone/>
+              <a:defRPr sz="900" b="1">
+                <a:solidFill>
+                  <a:srgbClr val="198754"/>
+                </a:solidFill>
+                <a:latin typeface="-apple-system"/>
+                <a:ea typeface="-apple-system"/>
+                <a:cs typeface="-apple-system"/>
+              </a:defRPr>
+            </a:pPr>
+            <a:r>
+              <a:rPr sz="900" b="1">
+                <a:solidFill>
+                  <a:srgbClr val="198754"/>
+                </a:solidFill>
+                <a:latin typeface="-apple-system"/>
+                <a:ea typeface="-apple-system"/>
+                <a:cs typeface="-apple-system"/>
+              </a:rPr>
+              <a:t>[1.37, 3.09]</a:t>
+            </a:r>
+          </a:p>
+        </p:txBody>
+      </p:sp>
+      <p:sp>
+        <p:nvSpPr>
+          <p:cNvPr id="43" name="round-unit">
+            <a:extLst xmlns:a="http://schemas.openxmlformats.org/drawingml/2006/main">
+              <a:ext uri="{FF2B5EF4-FFF2-40B4-BE49-F238E27FC236}">
+                <a16:creationId xmlns:a16="http://schemas.microsoft.com/office/drawing/2014/main" id="{F8A87708-1D29-4485-8670-B8C4D8039250}"/>
+              </a:ext>
+            </a:extLst>
+          </p:cNvPr>
+          <p:cNvSpPr>
+            <a:spLocks xmlns:a="http://schemas.openxmlformats.org/drawingml/2006/main" noGrp="1"/>
+          </p:cNvSpPr>
+          <p:nvPr/>
+        </p:nvSpPr>
+        <p:spPr>
+          <a:xfrm xmlns:a="http://schemas.openxmlformats.org/drawingml/2006/main">
+            <a:off x="6572250" y="3333750"/>
+            <a:ext cx="2000250" cy="400050"/>
           </a:xfrm>
           <a:prstGeom xmlns:a="http://schemas.openxmlformats.org/drawingml/2006/main" prst="rect">
             <a:avLst/>
@@ -11161,15 +11639,15 @@
         </p:spPr>
         <p:txBody>
           <a:bodyPr xmlns:a="http://schemas.openxmlformats.org/drawingml/2006/main" wrap="square" lIns="0" tIns="0" rIns="0" bIns="0" anchor="t">
-            <a:normAutofit/>
-          </a:bodyPr>
-          <a:lstStyle xmlns:a="http://schemas.openxmlformats.org/drawingml/2006/main"/>
-          <a:p xmlns:a="http://schemas.openxmlformats.org/drawingml/2006/main">
-            <a:pPr algn="l">
-              <a:buNone/>
-              <a:defRPr sz="863" b="1">
-                <a:solidFill>
-                  <a:srgbClr val="17212B"/>
+            <a:normAutofit fontScale="100000"/>
+          </a:bodyPr>
+          <a:lstStyle xmlns:a="http://schemas.openxmlformats.org/drawingml/2006/main"/>
+          <a:p xmlns:a="http://schemas.openxmlformats.org/drawingml/2006/main">
+            <a:pPr algn="r">
+              <a:buNone/>
+              <a:defRPr sz="788" b="0">
+                <a:solidFill>
+                  <a:srgbClr val="5D6874"/>
                 </a:solidFill>
                 <a:latin typeface="-apple-system"/>
                 <a:ea typeface="-apple-system"/>
@@ -11177,58 +11655,23 @@
               </a:defRPr>
             </a:pPr>
             <a:r>
-              <a:rPr sz="863" b="1">
-                <a:solidFill>
-                  <a:srgbClr val="17212B"/>
-                </a:solidFill>
-                <a:latin typeface="-apple-system"/>
-                <a:ea typeface="-apple-system"/>
-                <a:cs typeface="-apple-system"/>
-              </a:rPr>
-              <a:t>Gap → Dielectric</a:t>
-            </a:r>
-          </a:p>
-        </p:txBody>
-      </p:sp>
-      <p:sp>
-        <p:nvSpPr>
-          <p:cNvPr id="40" name="round-value-2">
-            <a:extLst xmlns:a="http://schemas.openxmlformats.org/drawingml/2006/main">
-              <a:ext uri="{FF2B5EF4-FFF2-40B4-BE49-F238E27FC236}">
-                <a16:creationId xmlns:a16="http://schemas.microsoft.com/office/drawing/2014/main" id="{69CFAF51-C1C7-40D4-872C-531E7D11C6E4}"/>
-              </a:ext>
-            </a:extLst>
-          </p:cNvPr>
-          <p:cNvSpPr>
-            <a:spLocks xmlns:a="http://schemas.openxmlformats.org/drawingml/2006/main" noGrp="1"/>
-          </p:cNvSpPr>
-          <p:nvPr/>
-        </p:nvSpPr>
-        <p:spPr>
-          <a:xfrm xmlns:a="http://schemas.openxmlformats.org/drawingml/2006/main">
-            <a:off x="7810500" y="2590800"/>
-            <a:ext cx="762000" cy="266700"/>
-          </a:xfrm>
-          <a:prstGeom xmlns:a="http://schemas.openxmlformats.org/drawingml/2006/main" prst="rect">
-            <a:avLst/>
-          </a:prstGeom>
-          <a:noFill xmlns:a="http://schemas.openxmlformats.org/drawingml/2006/main"/>
-          <a:ln xmlns:a="http://schemas.openxmlformats.org/drawingml/2006/main" w="0">
-            <a:noFill/>
-            <a:prstDash val="solid"/>
-          </a:ln>
-        </p:spPr>
-        <p:txBody>
-          <a:bodyPr xmlns:a="http://schemas.openxmlformats.org/drawingml/2006/main" wrap="square" lIns="0" tIns="0" rIns="0" bIns="0" anchor="t">
-            <a:normAutofit/>
-          </a:bodyPr>
-          <a:lstStyle xmlns:a="http://schemas.openxmlformats.org/drawingml/2006/main"/>
+              <a:rPr sz="788" b="0">
+                <a:solidFill>
+                  <a:srgbClr val="5D6874"/>
+                </a:solidFill>
+                <a:latin typeface="-apple-system"/>
+                <a:ea typeface="-apple-system"/>
+                <a:cs typeface="-apple-system"/>
+              </a:rPr>
+              <a:t>第一行：matched-final saving（95% CI）</a:t>
+            </a:r>
+          </a:p>
           <a:p xmlns:a="http://schemas.openxmlformats.org/drawingml/2006/main">
             <a:pPr algn="r">
               <a:buNone/>
-              <a:defRPr sz="900" b="1">
-                <a:solidFill>
-                  <a:srgbClr val="198754"/>
+              <a:defRPr sz="788" b="0">
+                <a:solidFill>
+                  <a:srgbClr val="5D6874"/>
                 </a:solidFill>
                 <a:latin typeface="-apple-system"/>
                 <a:ea typeface="-apple-system"/>
@@ -11236,192 +11679,15 @@
               </a:defRPr>
             </a:pPr>
             <a:r>
-              <a:rPr sz="900" b="1">
-                <a:solidFill>
-                  <a:srgbClr val="198754"/>
-                </a:solidFill>
-                <a:latin typeface="-apple-system"/>
-                <a:ea typeface="-apple-system"/>
-                <a:cs typeface="-apple-system"/>
-              </a:rPr>
-              <a:t>5.03 / 8.46</a:t>
-            </a:r>
-          </a:p>
-        </p:txBody>
-      </p:sp>
-      <p:sp>
-        <p:nvSpPr>
-          <p:cNvPr id="41" name="round-label-3">
-            <a:extLst xmlns:a="http://schemas.openxmlformats.org/drawingml/2006/main">
-              <a:ext uri="{FF2B5EF4-FFF2-40B4-BE49-F238E27FC236}">
-                <a16:creationId xmlns:a16="http://schemas.microsoft.com/office/drawing/2014/main" id="{AB86BC24-A58E-4B67-A3BC-FB59CD9C52C0}"/>
-              </a:ext>
-            </a:extLst>
-          </p:cNvPr>
-          <p:cNvSpPr>
-            <a:spLocks xmlns:a="http://schemas.openxmlformats.org/drawingml/2006/main" noGrp="1"/>
-          </p:cNvSpPr>
-          <p:nvPr/>
-        </p:nvSpPr>
-        <p:spPr>
-          <a:xfrm xmlns:a="http://schemas.openxmlformats.org/drawingml/2006/main">
-            <a:off x="6572250" y="3019425"/>
-            <a:ext cx="1190625" cy="266700"/>
-          </a:xfrm>
-          <a:prstGeom xmlns:a="http://schemas.openxmlformats.org/drawingml/2006/main" prst="rect">
-            <a:avLst/>
-          </a:prstGeom>
-          <a:noFill xmlns:a="http://schemas.openxmlformats.org/drawingml/2006/main"/>
-          <a:ln xmlns:a="http://schemas.openxmlformats.org/drawingml/2006/main" w="0">
-            <a:noFill/>
-            <a:prstDash val="solid"/>
-          </a:ln>
-        </p:spPr>
-        <p:txBody>
-          <a:bodyPr xmlns:a="http://schemas.openxmlformats.org/drawingml/2006/main" wrap="square" lIns="0" tIns="0" rIns="0" bIns="0" anchor="t">
-            <a:normAutofit/>
-          </a:bodyPr>
-          <a:lstStyle xmlns:a="http://schemas.openxmlformats.org/drawingml/2006/main"/>
-          <a:p xmlns:a="http://schemas.openxmlformats.org/drawingml/2006/main">
-            <a:pPr algn="l">
-              <a:buNone/>
-              <a:defRPr sz="863" b="1">
-                <a:solidFill>
-                  <a:srgbClr val="17212B"/>
-                </a:solidFill>
-                <a:latin typeface="-apple-system"/>
-                <a:ea typeface="-apple-system"/>
-                <a:cs typeface="-apple-system"/>
-              </a:defRPr>
-            </a:pPr>
-            <a:r>
-              <a:rPr sz="863" b="1">
-                <a:solidFill>
-                  <a:srgbClr val="17212B"/>
-                </a:solidFill>
-                <a:latin typeface="-apple-system"/>
-                <a:ea typeface="-apple-system"/>
-                <a:cs typeface="-apple-system"/>
-              </a:rPr>
-              <a:t>FreeSolv → Lipo</a:t>
-            </a:r>
-          </a:p>
-        </p:txBody>
-      </p:sp>
-      <p:sp>
-        <p:nvSpPr>
-          <p:cNvPr id="42" name="round-value-3">
-            <a:extLst xmlns:a="http://schemas.openxmlformats.org/drawingml/2006/main">
-              <a:ext uri="{FF2B5EF4-FFF2-40B4-BE49-F238E27FC236}">
-                <a16:creationId xmlns:a16="http://schemas.microsoft.com/office/drawing/2014/main" id="{BBAFFDA6-7421-4275-A8B9-412451E96210}"/>
-              </a:ext>
-            </a:extLst>
-          </p:cNvPr>
-          <p:cNvSpPr>
-            <a:spLocks xmlns:a="http://schemas.openxmlformats.org/drawingml/2006/main" noGrp="1"/>
-          </p:cNvSpPr>
-          <p:nvPr/>
-        </p:nvSpPr>
-        <p:spPr>
-          <a:xfrm xmlns:a="http://schemas.openxmlformats.org/drawingml/2006/main">
-            <a:off x="7810500" y="3019425"/>
-            <a:ext cx="762000" cy="266700"/>
-          </a:xfrm>
-          <a:prstGeom xmlns:a="http://schemas.openxmlformats.org/drawingml/2006/main" prst="rect">
-            <a:avLst/>
-          </a:prstGeom>
-          <a:noFill xmlns:a="http://schemas.openxmlformats.org/drawingml/2006/main"/>
-          <a:ln xmlns:a="http://schemas.openxmlformats.org/drawingml/2006/main" w="0">
-            <a:noFill/>
-            <a:prstDash val="solid"/>
-          </a:ln>
-        </p:spPr>
-        <p:txBody>
-          <a:bodyPr xmlns:a="http://schemas.openxmlformats.org/drawingml/2006/main" wrap="square" lIns="0" tIns="0" rIns="0" bIns="0" anchor="t">
-            <a:normAutofit/>
-          </a:bodyPr>
-          <a:lstStyle xmlns:a="http://schemas.openxmlformats.org/drawingml/2006/main"/>
-          <a:p xmlns:a="http://schemas.openxmlformats.org/drawingml/2006/main">
-            <a:pPr algn="r">
-              <a:buNone/>
-              <a:defRPr sz="900" b="1">
-                <a:solidFill>
-                  <a:srgbClr val="198754"/>
-                </a:solidFill>
-                <a:latin typeface="-apple-system"/>
-                <a:ea typeface="-apple-system"/>
-                <a:cs typeface="-apple-system"/>
-              </a:defRPr>
-            </a:pPr>
-            <a:r>
-              <a:rPr sz="900" b="1">
-                <a:solidFill>
-                  <a:srgbClr val="198754"/>
-                </a:solidFill>
-                <a:latin typeface="-apple-system"/>
-                <a:ea typeface="-apple-system"/>
-                <a:cs typeface="-apple-system"/>
-              </a:rPr>
-              <a:t>2.23 / 4.80</a:t>
-            </a:r>
-          </a:p>
-        </p:txBody>
-      </p:sp>
-      <p:sp>
-        <p:nvSpPr>
-          <p:cNvPr id="43" name="round-unit">
-            <a:extLst xmlns:a="http://schemas.openxmlformats.org/drawingml/2006/main">
-              <a:ext uri="{FF2B5EF4-FFF2-40B4-BE49-F238E27FC236}">
-                <a16:creationId xmlns:a16="http://schemas.microsoft.com/office/drawing/2014/main" id="{F8A87708-1D29-4485-8670-B8C4D8039250}"/>
-              </a:ext>
-            </a:extLst>
-          </p:cNvPr>
-          <p:cNvSpPr>
-            <a:spLocks xmlns:a="http://schemas.openxmlformats.org/drawingml/2006/main" noGrp="1"/>
-          </p:cNvSpPr>
-          <p:nvPr/>
-        </p:nvSpPr>
-        <p:spPr>
-          <a:xfrm xmlns:a="http://schemas.openxmlformats.org/drawingml/2006/main">
-            <a:off x="6572250" y="3409950"/>
-            <a:ext cx="2000250" cy="228600"/>
-          </a:xfrm>
-          <a:prstGeom xmlns:a="http://schemas.openxmlformats.org/drawingml/2006/main" prst="rect">
-            <a:avLst/>
-          </a:prstGeom>
-          <a:noFill xmlns:a="http://schemas.openxmlformats.org/drawingml/2006/main"/>
-          <a:ln xmlns:a="http://schemas.openxmlformats.org/drawingml/2006/main" w="0">
-            <a:noFill/>
-            <a:prstDash val="solid"/>
-          </a:ln>
-        </p:spPr>
-        <p:txBody>
-          <a:bodyPr xmlns:a="http://schemas.openxmlformats.org/drawingml/2006/main" wrap="square" lIns="0" tIns="0" rIns="0" bIns="0" anchor="t">
-            <a:normAutofit/>
-          </a:bodyPr>
-          <a:lstStyle xmlns:a="http://schemas.openxmlformats.org/drawingml/2006/main"/>
-          <a:p xmlns:a="http://schemas.openxmlformats.org/drawingml/2006/main">
-            <a:pPr algn="r">
-              <a:buNone/>
-              <a:defRPr sz="788" b="0">
+              <a:rPr sz="788" b="0">
                 <a:solidFill>
                   <a:srgbClr val="5D6874"/>
                 </a:solidFill>
                 <a:latin typeface="-apple-system"/>
                 <a:ea typeface="-apple-system"/>
                 <a:cs typeface="-apple-system"/>
-              </a:defRPr>
-            </a:pPr>
-            <a:r>
-              <a:rPr sz="788" b="0">
-                <a:solidFill>
-                  <a:srgbClr val="5D6874"/>
-                </a:solidFill>
-                <a:latin typeface="-apple-system"/>
-                <a:ea typeface="-apple-system"/>
-                <a:cs typeface="-apple-system"/>
-              </a:rPr>
-              <a:t>matched-final / global-top10</a:t>
+              </a:rPr>
+              <a:t>另测 global-top10：3.62 / 9.57 / 8.46 / 4.80</a:t>
             </a:r>
           </a:p>
         </p:txBody>
@@ -11462,7 +11728,7 @@
         </p:spPr>
         <p:txBody>
           <a:bodyPr xmlns:a="http://schemas.openxmlformats.org/drawingml/2006/main" wrap="square" lIns="114300" tIns="95250" rIns="114300" bIns="95250" anchor="t">
-            <a:normAutofit fontScale="98361" lnSpcReduction="10000"/>
+            <a:normAutofit fontScale="100000" lnSpcReduction="10000"/>
           </a:bodyPr>
           <a:lstStyle xmlns:a="http://schemas.openxmlformats.org/drawingml/2006/main"/>
           <a:p xmlns:a="http://schemas.openxmlformats.org/drawingml/2006/main">
@@ -11486,7 +11752,7 @@
                 <a:ea typeface="-apple-system"/>
                 <a:cs typeface="-apple-system"/>
               </a:rPr>
-              <a:t>边际收益递减：现有数据只显示早期 gain 通常高于 final-round gain。若要证明饱和，需要在不同历史经验数量下重跑，并以 95% CI（不确定性区间）和饱和模型比较验证。</a:t>
+              <a:t>右侧括号已给出 paired 95% CI。当前只能说迁移减少了达到基准质量所需轮数；若要证明“边际收益递减”，还需改变可用历史经验量后重跑并比较饱和模型。</a:t>
             </a:r>
           </a:p>
         </p:txBody>
@@ -11587,7 +11853,7 @@
           <p:nvPr/>
         </p:nvPicPr>
         <p:blipFill>
-          <a:blip xmlns:r="http://schemas.openxmlformats.org/officeDocument/2006/relationships" xmlns:a="http://schemas.openxmlformats.org/drawingml/2006/main" r:embed="R91e825efdb6c4c5b"/>
+          <a:blip xmlns:r="http://schemas.openxmlformats.org/officeDocument/2006/relationships" xmlns:a="http://schemas.openxmlformats.org/drawingml/2006/main" r:embed="R3c6142faa94542f9"/>
           <a:stretch xmlns:a="http://schemas.openxmlformats.org/drawingml/2006/main">
             <a:fillRect l="0" t="0" r="0" b="0"/>
           </a:stretch>
@@ -13012,7 +13278,7 @@
           <p:nvPr/>
         </p:nvPicPr>
         <p:blipFill>
-          <a:blip xmlns:r="http://schemas.openxmlformats.org/officeDocument/2006/relationships" xmlns:a="http://schemas.openxmlformats.org/drawingml/2006/main" r:embed="Rcf10cbb3d209427d"/>
+          <a:blip xmlns:r="http://schemas.openxmlformats.org/officeDocument/2006/relationships" xmlns:a="http://schemas.openxmlformats.org/drawingml/2006/main" r:embed="R18fb4cf41b6344c6"/>
           <a:stretch xmlns:a="http://schemas.openxmlformats.org/drawingml/2006/main">
             <a:fillRect l="0" t="0" r="0" b="0"/>
           </a:stretch>
@@ -14354,7 +14620,7 @@
           <p:nvPr/>
         </p:nvPicPr>
         <p:blipFill>
-          <a:blip xmlns:r="http://schemas.openxmlformats.org/officeDocument/2006/relationships" xmlns:a="http://schemas.openxmlformats.org/drawingml/2006/main" r:embed="R8fa514bb3ea54d7b"/>
+          <a:blip xmlns:r="http://schemas.openxmlformats.org/officeDocument/2006/relationships" xmlns:a="http://schemas.openxmlformats.org/drawingml/2006/main" r:embed="R4f2342f49fce4093"/>
           <a:stretch xmlns:a="http://schemas.openxmlformats.org/drawingml/2006/main">
             <a:fillRect l="0" t="0" r="0" b="0"/>
           </a:stretch>
@@ -15705,7 +15971,7 @@
           <p:nvPr/>
         </p:nvPicPr>
         <p:blipFill>
-          <a:blip xmlns:r="http://schemas.openxmlformats.org/officeDocument/2006/relationships" xmlns:a="http://schemas.openxmlformats.org/drawingml/2006/main" r:embed="Rc39a55965a9d4e6f"/>
+          <a:blip xmlns:r="http://schemas.openxmlformats.org/officeDocument/2006/relationships" xmlns:a="http://schemas.openxmlformats.org/drawingml/2006/main" r:embed="Rce65d3ca4f6f4313"/>
           <a:stretch xmlns:a="http://schemas.openxmlformats.org/drawingml/2006/main">
             <a:fillRect l="0" t="0" r="0" b="0"/>
           </a:stretch>
@@ -15873,7 +16139,7 @@
           <p:nvPr/>
         </p:nvPicPr>
         <p:blipFill>
-          <a:blip xmlns:r="http://schemas.openxmlformats.org/officeDocument/2006/relationships" xmlns:a="http://schemas.openxmlformats.org/drawingml/2006/main" r:embed="R10122cff42184685"/>
+          <a:blip xmlns:r="http://schemas.openxmlformats.org/officeDocument/2006/relationships" xmlns:a="http://schemas.openxmlformats.org/drawingml/2006/main" r:embed="R4f2d7ec3388b40c0"/>
           <a:stretch xmlns:a="http://schemas.openxmlformats.org/drawingml/2006/main">
             <a:fillRect l="0" t="0" r="0" b="0"/>
           </a:stretch>
@@ -16714,7 +16980,7 @@
           <p:nvPr/>
         </p:nvPicPr>
         <p:blipFill>
-          <a:blip xmlns:r="http://schemas.openxmlformats.org/officeDocument/2006/relationships" xmlns:a="http://schemas.openxmlformats.org/drawingml/2006/main" r:embed="Ref58e0972ee04142"/>
+          <a:blip xmlns:r="http://schemas.openxmlformats.org/officeDocument/2006/relationships" xmlns:a="http://schemas.openxmlformats.org/drawingml/2006/main" r:embed="Rff251568dd6a406a"/>
           <a:stretch xmlns:a="http://schemas.openxmlformats.org/drawingml/2006/main">
             <a:fillRect l="0" t="0" r="0" b="0"/>
           </a:stretch>
@@ -19630,7 +19896,7 @@
           <p:nvPr/>
         </p:nvPicPr>
         <p:blipFill>
-          <a:blip xmlns:r="http://schemas.openxmlformats.org/officeDocument/2006/relationships" xmlns:a="http://schemas.openxmlformats.org/drawingml/2006/main" r:embed="R3ceaba6e71cb4ee7"/>
+          <a:blip xmlns:r="http://schemas.openxmlformats.org/officeDocument/2006/relationships" xmlns:a="http://schemas.openxmlformats.org/drawingml/2006/main" r:embed="R72c148f7d93b43c9"/>
           <a:stretch xmlns:a="http://schemas.openxmlformats.org/drawingml/2006/main">
             <a:fillRect l="0" t="0" r="0" b="0"/>
           </a:stretch>
@@ -19798,7 +20064,7 @@
           <p:nvPr/>
         </p:nvPicPr>
         <p:blipFill>
-          <a:blip xmlns:r="http://schemas.openxmlformats.org/officeDocument/2006/relationships" xmlns:a="http://schemas.openxmlformats.org/drawingml/2006/main" r:embed="Rfc3c1ccd80014bb2"/>
+          <a:blip xmlns:r="http://schemas.openxmlformats.org/officeDocument/2006/relationships" xmlns:a="http://schemas.openxmlformats.org/drawingml/2006/main" r:embed="R5772ce2a34ce4dfb"/>
           <a:stretch xmlns:a="http://schemas.openxmlformats.org/drawingml/2006/main">
             <a:fillRect l="0" t="0" r="0" b="0"/>
           </a:stretch>
@@ -19979,7 +20245,7 @@
           <p:nvPr/>
         </p:nvPicPr>
         <p:blipFill>
-          <a:blip xmlns:r="http://schemas.openxmlformats.org/officeDocument/2006/relationships" xmlns:a="http://schemas.openxmlformats.org/drawingml/2006/main" r:embed="R1759ffb0a85a4c69"/>
+          <a:blip xmlns:r="http://schemas.openxmlformats.org/officeDocument/2006/relationships" xmlns:a="http://schemas.openxmlformats.org/drawingml/2006/main" r:embed="Rb95ce57965054f4d"/>
           <a:stretch xmlns:a="http://schemas.openxmlformats.org/drawingml/2006/main">
             <a:fillRect l="0" t="0" r="0" b="0"/>
           </a:stretch>
@@ -21645,7 +21911,7 @@
           <p:nvPr/>
         </p:nvPicPr>
         <p:blipFill>
-          <a:blip xmlns:r="http://schemas.openxmlformats.org/officeDocument/2006/relationships" xmlns:a="http://schemas.openxmlformats.org/drawingml/2006/main" r:embed="Rfdf211384e834373"/>
+          <a:blip xmlns:r="http://schemas.openxmlformats.org/officeDocument/2006/relationships" xmlns:a="http://schemas.openxmlformats.org/drawingml/2006/main" r:embed="Rf8ee82c03170453e"/>
           <a:stretch xmlns:a="http://schemas.openxmlformats.org/drawingml/2006/main">
             <a:fillRect l="0" t="0" r="0" b="0"/>
           </a:stretch>
@@ -21813,7 +22079,7 @@
           <p:nvPr/>
         </p:nvPicPr>
         <p:blipFill>
-          <a:blip xmlns:r="http://schemas.openxmlformats.org/officeDocument/2006/relationships" xmlns:a="http://schemas.openxmlformats.org/drawingml/2006/main" r:embed="R005fc53d502f418a"/>
+          <a:blip xmlns:r="http://schemas.openxmlformats.org/officeDocument/2006/relationships" xmlns:a="http://schemas.openxmlformats.org/drawingml/2006/main" r:embed="R691bcb8229874bea"/>
           <a:stretch xmlns:a="http://schemas.openxmlformats.org/drawingml/2006/main">
             <a:fillRect l="0" t="0" r="0" b="0"/>
           </a:stretch>
@@ -21994,7 +22260,7 @@
           <p:nvPr/>
         </p:nvPicPr>
         <p:blipFill>
-          <a:blip xmlns:r="http://schemas.openxmlformats.org/officeDocument/2006/relationships" xmlns:a="http://schemas.openxmlformats.org/drawingml/2006/main" r:embed="R666494f129bb4a3f"/>
+          <a:blip xmlns:r="http://schemas.openxmlformats.org/officeDocument/2006/relationships" xmlns:a="http://schemas.openxmlformats.org/drawingml/2006/main" r:embed="Rce14f0c7b1634f53"/>
           <a:stretch xmlns:a="http://schemas.openxmlformats.org/drawingml/2006/main">
             <a:fillRect l="0" t="0" r="0" b="0"/>
           </a:stretch>
@@ -23665,7 +23931,7 @@
           <p:nvPr/>
         </p:nvPicPr>
         <p:blipFill>
-          <a:blip xmlns:r="http://schemas.openxmlformats.org/officeDocument/2006/relationships" xmlns:a="http://schemas.openxmlformats.org/drawingml/2006/main" r:embed="R0e3aaed7bace4d18"/>
+          <a:blip xmlns:r="http://schemas.openxmlformats.org/officeDocument/2006/relationships" xmlns:a="http://schemas.openxmlformats.org/drawingml/2006/main" r:embed="Rd9fb8b753b514745"/>
           <a:stretch xmlns:a="http://schemas.openxmlformats.org/drawingml/2006/main">
             <a:fillRect l="0" t="0" r="0" b="0"/>
           </a:stretch>
@@ -25342,7 +25608,7 @@
           <p:nvPr/>
         </p:nvPicPr>
         <p:blipFill>
-          <a:blip xmlns:r="http://schemas.openxmlformats.org/officeDocument/2006/relationships" xmlns:a="http://schemas.openxmlformats.org/drawingml/2006/main" r:embed="Rdfa1d15027cc4696"/>
+          <a:blip xmlns:r="http://schemas.openxmlformats.org/officeDocument/2006/relationships" xmlns:a="http://schemas.openxmlformats.org/drawingml/2006/main" r:embed="Raad4ed028fde4063"/>
           <a:stretch xmlns:a="http://schemas.openxmlformats.org/drawingml/2006/main">
             <a:fillRect l="0" t="0" r="0" b="0"/>
           </a:stretch>
@@ -26983,7 +27249,7 @@
           <p:nvPr/>
         </p:nvPicPr>
         <p:blipFill>
-          <a:blip xmlns:r="http://schemas.openxmlformats.org/officeDocument/2006/relationships" xmlns:a="http://schemas.openxmlformats.org/drawingml/2006/main" r:embed="R35549734415b45f4"/>
+          <a:blip xmlns:r="http://schemas.openxmlformats.org/officeDocument/2006/relationships" xmlns:a="http://schemas.openxmlformats.org/drawingml/2006/main" r:embed="Ra2f5ce37b19f4398"/>
           <a:stretch xmlns:a="http://schemas.openxmlformats.org/drawingml/2006/main">
             <a:fillRect l="0" t="0" r="0" b="0"/>
           </a:stretch>
@@ -27151,7 +27417,7 @@
           <p:nvPr/>
         </p:nvPicPr>
         <p:blipFill>
-          <a:blip xmlns:r="http://schemas.openxmlformats.org/officeDocument/2006/relationships" xmlns:a="http://schemas.openxmlformats.org/drawingml/2006/main" r:embed="R1da9ce57d51f4764"/>
+          <a:blip xmlns:r="http://schemas.openxmlformats.org/officeDocument/2006/relationships" xmlns:a="http://schemas.openxmlformats.org/drawingml/2006/main" r:embed="R58b5906b512d46af"/>
           <a:stretch xmlns:a="http://schemas.openxmlformats.org/drawingml/2006/main">
             <a:fillRect l="0" t="0" r="0" b="0"/>
           </a:stretch>
@@ -27566,7 +27832,7 @@
           <p:nvPr/>
         </p:nvPicPr>
         <p:blipFill>
-          <a:blip xmlns:r="http://schemas.openxmlformats.org/officeDocument/2006/relationships" xmlns:a="http://schemas.openxmlformats.org/drawingml/2006/main" r:embed="R4388970d013c40d1"/>
+          <a:blip xmlns:r="http://schemas.openxmlformats.org/officeDocument/2006/relationships" xmlns:a="http://schemas.openxmlformats.org/drawingml/2006/main" r:embed="Rdb09470b67c04efa"/>
           <a:stretch xmlns:a="http://schemas.openxmlformats.org/drawingml/2006/main"/>
         </p:blipFill>
         <p:spPr>
@@ -27675,7 +27941,7 @@
           <p:nvPr/>
         </p:nvPicPr>
         <p:blipFill>
-          <a:blip xmlns:r="http://schemas.openxmlformats.org/officeDocument/2006/relationships" xmlns:a="http://schemas.openxmlformats.org/drawingml/2006/main" r:embed="R28eca2c634f542b4"/>
+          <a:blip xmlns:r="http://schemas.openxmlformats.org/officeDocument/2006/relationships" xmlns:a="http://schemas.openxmlformats.org/drawingml/2006/main" r:embed="R12c5bc9ab3bf48e3"/>
           <a:stretch xmlns:a="http://schemas.openxmlformats.org/drawingml/2006/main">
             <a:fillRect l="0" t="0" r="0" b="0"/>
           </a:stretch>
@@ -27843,7 +28109,7 @@
           <p:nvPr/>
         </p:nvPicPr>
         <p:blipFill>
-          <a:blip xmlns:r="http://schemas.openxmlformats.org/officeDocument/2006/relationships" xmlns:a="http://schemas.openxmlformats.org/drawingml/2006/main" r:embed="R4c1ec0e3d2bf4674"/>
+          <a:blip xmlns:r="http://schemas.openxmlformats.org/officeDocument/2006/relationships" xmlns:a="http://schemas.openxmlformats.org/drawingml/2006/main" r:embed="R12c0d2a51a3f40b1"/>
           <a:stretch xmlns:a="http://schemas.openxmlformats.org/drawingml/2006/main">
             <a:fillRect l="0" t="0" r="0" b="0"/>
           </a:stretch>
@@ -27867,7 +28133,7 @@
           <p:nvPr/>
         </p:nvPicPr>
         <p:blipFill>
-          <a:blip xmlns:r="http://schemas.openxmlformats.org/officeDocument/2006/relationships" xmlns:a="http://schemas.openxmlformats.org/drawingml/2006/main" r:embed="Rc647ed287f384b18"/>
+          <a:blip xmlns:r="http://schemas.openxmlformats.org/officeDocument/2006/relationships" xmlns:a="http://schemas.openxmlformats.org/drawingml/2006/main" r:embed="R77bce8a2cfda42e4"/>
           <a:stretch xmlns:a="http://schemas.openxmlformats.org/drawingml/2006/main">
             <a:fillRect l="0" t="0" r="0" b="0"/>
           </a:stretch>
@@ -28042,7 +28308,7 @@
           <p:nvPr/>
         </p:nvPicPr>
         <p:blipFill>
-          <a:blip xmlns:r="http://schemas.openxmlformats.org/officeDocument/2006/relationships" xmlns:a="http://schemas.openxmlformats.org/drawingml/2006/main" r:embed="Rfb284c43fb484b61"/>
+          <a:blip xmlns:r="http://schemas.openxmlformats.org/officeDocument/2006/relationships" xmlns:a="http://schemas.openxmlformats.org/drawingml/2006/main" r:embed="R94e32ea86a354201"/>
           <a:stretch xmlns:a="http://schemas.openxmlformats.org/drawingml/2006/main">
             <a:fillRect l="0" t="0" r="0" b="0"/>
           </a:stretch>
@@ -28140,7 +28406,7 @@
           <p:nvPr/>
         </p:nvPicPr>
         <p:blipFill>
-          <a:blip xmlns:r="http://schemas.openxmlformats.org/officeDocument/2006/relationships" xmlns:a="http://schemas.openxmlformats.org/drawingml/2006/main" r:embed="R7227abdeaaff4bb0"/>
+          <a:blip xmlns:r="http://schemas.openxmlformats.org/officeDocument/2006/relationships" xmlns:a="http://schemas.openxmlformats.org/drawingml/2006/main" r:embed="R1a57b8f031ac4083"/>
           <a:stretch xmlns:a="http://schemas.openxmlformats.org/drawingml/2006/main">
             <a:fillRect l="0" t="0" r="0" b="0"/>
           </a:stretch>
@@ -28238,7 +28504,7 @@
           <p:nvPr/>
         </p:nvPicPr>
         <p:blipFill>
-          <a:blip xmlns:r="http://schemas.openxmlformats.org/officeDocument/2006/relationships" xmlns:a="http://schemas.openxmlformats.org/drawingml/2006/main" r:embed="Rf9b5e92eb9154de1"/>
+          <a:blip xmlns:r="http://schemas.openxmlformats.org/officeDocument/2006/relationships" xmlns:a="http://schemas.openxmlformats.org/drawingml/2006/main" r:embed="R559e77f9694f469d"/>
           <a:stretch xmlns:a="http://schemas.openxmlformats.org/drawingml/2006/main">
             <a:fillRect l="0" t="0" r="0" b="0"/>
           </a:stretch>
@@ -28336,7 +28602,7 @@
           <p:nvPr/>
         </p:nvPicPr>
         <p:blipFill>
-          <a:blip xmlns:r="http://schemas.openxmlformats.org/officeDocument/2006/relationships" xmlns:a="http://schemas.openxmlformats.org/drawingml/2006/main" r:embed="R7227abdeaaff4bb0"/>
+          <a:blip xmlns:r="http://schemas.openxmlformats.org/officeDocument/2006/relationships" xmlns:a="http://schemas.openxmlformats.org/drawingml/2006/main" r:embed="R1a57b8f031ac4083"/>
           <a:stretch xmlns:a="http://schemas.openxmlformats.org/drawingml/2006/main">
             <a:fillRect l="0" t="0" r="0" b="0"/>
           </a:stretch>
@@ -28434,7 +28700,7 @@
           <p:nvPr/>
         </p:nvPicPr>
         <p:blipFill>
-          <a:blip xmlns:r="http://schemas.openxmlformats.org/officeDocument/2006/relationships" xmlns:a="http://schemas.openxmlformats.org/drawingml/2006/main" r:embed="Rf9b5e92eb9154de1"/>
+          <a:blip xmlns:r="http://schemas.openxmlformats.org/officeDocument/2006/relationships" xmlns:a="http://schemas.openxmlformats.org/drawingml/2006/main" r:embed="R559e77f9694f469d"/>
           <a:stretch xmlns:a="http://schemas.openxmlformats.org/drawingml/2006/main">
             <a:fillRect l="0" t="0" r="0" b="0"/>
           </a:stretch>
@@ -28532,7 +28798,7 @@
           <p:nvPr/>
         </p:nvPicPr>
         <p:blipFill>
-          <a:blip xmlns:r="http://schemas.openxmlformats.org/officeDocument/2006/relationships" xmlns:a="http://schemas.openxmlformats.org/drawingml/2006/main" r:embed="R7227abdeaaff4bb0"/>
+          <a:blip xmlns:r="http://schemas.openxmlformats.org/officeDocument/2006/relationships" xmlns:a="http://schemas.openxmlformats.org/drawingml/2006/main" r:embed="R1a57b8f031ac4083"/>
           <a:stretch xmlns:a="http://schemas.openxmlformats.org/drawingml/2006/main">
             <a:fillRect l="0" t="0" r="0" b="0"/>
           </a:stretch>
@@ -28630,7 +28896,7 @@
           <p:nvPr/>
         </p:nvPicPr>
         <p:blipFill>
-          <a:blip xmlns:r="http://schemas.openxmlformats.org/officeDocument/2006/relationships" xmlns:a="http://schemas.openxmlformats.org/drawingml/2006/main" r:embed="Rf9b5e92eb9154de1"/>
+          <a:blip xmlns:r="http://schemas.openxmlformats.org/officeDocument/2006/relationships" xmlns:a="http://schemas.openxmlformats.org/drawingml/2006/main" r:embed="R559e77f9694f469d"/>
           <a:stretch xmlns:a="http://schemas.openxmlformats.org/drawingml/2006/main">
             <a:fillRect l="0" t="0" r="0" b="0"/>
           </a:stretch>
@@ -28734,7 +29000,7 @@
           <p:nvPr/>
         </p:nvPicPr>
         <p:blipFill>
-          <a:blip xmlns:r="http://schemas.openxmlformats.org/officeDocument/2006/relationships" xmlns:a="http://schemas.openxmlformats.org/drawingml/2006/main" r:embed="R94efad05b1b4462d"/>
+          <a:blip xmlns:r="http://schemas.openxmlformats.org/officeDocument/2006/relationships" xmlns:a="http://schemas.openxmlformats.org/drawingml/2006/main" r:embed="R9c2e14f0bccc4b97"/>
           <a:stretch xmlns:a="http://schemas.openxmlformats.org/drawingml/2006/main"/>
         </p:blipFill>
         <p:spPr>

</xml_diff>